<commit_message>
Polish public hackathon submission
</commit_message>
<xml_diff>
--- a/submission/Dispatch-IGNITE-Hackathon-Deck.pptx
+++ b/submission/Dispatch-IGNITE-Hackathon-Deck.pptx
@@ -2,19 +2,19 @@
 <file path=ppt/presentation.xml><?xml version="1.0" encoding="utf-8"?>
 <p:presentation xmlns:p="http://schemas.openxmlformats.org/presentationml/2006/main">
   <p:sldMasterIdLst>
-    <p:sldMasterId xmlns:r="http://schemas.openxmlformats.org/officeDocument/2006/relationships" id="2147483648" r:id="Rc1eb2b921260482a"/>
+    <p:sldMasterId xmlns:r="http://schemas.openxmlformats.org/officeDocument/2006/relationships" id="2147483648" r:id="R15d76c1d559c4558"/>
   </p:sldMasterIdLst>
   <p:notesMasterIdLst>
-    <p:notesMasterId xmlns:r="http://schemas.openxmlformats.org/officeDocument/2006/relationships" r:id="R306e777d3fd34d85"/>
+    <p:notesMasterId xmlns:r="http://schemas.openxmlformats.org/officeDocument/2006/relationships" r:id="R4fa81803c15b4ae0"/>
   </p:notesMasterIdLst>
   <p:sldIdLst>
-    <p:sldId xmlns:r="http://schemas.openxmlformats.org/officeDocument/2006/relationships" id="256" r:id="Rf779630832234367"/>
-    <p:sldId xmlns:r="http://schemas.openxmlformats.org/officeDocument/2006/relationships" id="257" r:id="R739299bb70844904"/>
-    <p:sldId xmlns:r="http://schemas.openxmlformats.org/officeDocument/2006/relationships" id="258" r:id="R4138c61ba19241cb"/>
-    <p:sldId xmlns:r="http://schemas.openxmlformats.org/officeDocument/2006/relationships" id="259" r:id="R7cdaa96de6444552"/>
-    <p:sldId xmlns:r="http://schemas.openxmlformats.org/officeDocument/2006/relationships" id="260" r:id="Rfa2dbdb8ea1644db"/>
-    <p:sldId xmlns:r="http://schemas.openxmlformats.org/officeDocument/2006/relationships" id="261" r:id="R408cdc5523e548ae"/>
-    <p:sldId xmlns:r="http://schemas.openxmlformats.org/officeDocument/2006/relationships" id="262" r:id="R0b829b3f9df44384"/>
+    <p:sldId xmlns:r="http://schemas.openxmlformats.org/officeDocument/2006/relationships" id="256" r:id="Rf16ea1ad2b8a4dec"/>
+    <p:sldId xmlns:r="http://schemas.openxmlformats.org/officeDocument/2006/relationships" id="257" r:id="Raab8f7c631394185"/>
+    <p:sldId xmlns:r="http://schemas.openxmlformats.org/officeDocument/2006/relationships" id="258" r:id="Rf84876888181479c"/>
+    <p:sldId xmlns:r="http://schemas.openxmlformats.org/officeDocument/2006/relationships" id="259" r:id="Rc4b4ca6123e84fd3"/>
+    <p:sldId xmlns:r="http://schemas.openxmlformats.org/officeDocument/2006/relationships" id="260" r:id="Rb3c4c994d71d4a80"/>
+    <p:sldId xmlns:r="http://schemas.openxmlformats.org/officeDocument/2006/relationships" id="261" r:id="R74189d07a1e14815"/>
+    <p:sldId xmlns:r="http://schemas.openxmlformats.org/officeDocument/2006/relationships" id="262" r:id="Rc8e6178b577b428f"/>
   </p:sldIdLst>
   <p:sldSz cx="12192000" cy="6858000"/>
   <p:notesSz cx="6858000" cy="9144000"/>
@@ -448,7 +448,7 @@
           <a:lstStyle xmlns:a="http://schemas.openxmlformats.org/drawingml/2006/main"/>
           <a:p xmlns:a="http://schemas.openxmlformats.org/drawingml/2006/main">
             <a:r>
-              <a:t>Use case informed by the Floof.sg interview discussed by the team on 5 September 2026.</a:t>
+              <a:t>Real client use case: Floof.sg, attended fresh-pet-food delivery in Singapore.</a:t>
             </a:r>
           </a:p>
         </p:txBody>
@@ -518,7 +518,7 @@
           <a:lstStyle xmlns:a="http://schemas.openxmlformats.org/drawingml/2006/main"/>
           <a:p xmlns:a="http://schemas.openxmlformats.org/drawingml/2006/main">
             <a:r>
-              <a:t>Source for volume and interview statement: checked team discussion transcript, 5 September 2026. Figures are interview-reported, not independently measured.</a:t>
+              <a:t>Floof.sg handles 30–40 attended deliveries on a busy day. Customer availability and route feasibility must be solved together.</a:t>
             </a:r>
           </a:p>
         </p:txBody>
@@ -936,7 +936,7 @@
   </p:cSld>
   <p:clrMap bg1="lt1" tx1="dk1" bg2="lt2" tx2="dk2" accent1="accent1" accent2="accent2" accent3="accent3" accent4="accent4" accent5="accent5" accent6="accent6" hlink="hlink" folHlink="folHlink"/>
   <p:sldLayoutIdLst>
-    <p:sldLayoutId xmlns:r="http://schemas.openxmlformats.org/officeDocument/2006/relationships" id="2147483649" r:id="R51746894a6a54552"/>
+    <p:sldLayoutId xmlns:r="http://schemas.openxmlformats.org/officeDocument/2006/relationships" id="2147483649" r:id="R0f10f216083942e1"/>
   </p:sldLayoutIdLst>
   <p:txStyles>
     <p:titleStyle>
@@ -1487,7 +1487,7 @@
           <p:cNvPr id="29" name="">
             <a:extLst xmlns:a="http://schemas.openxmlformats.org/drawingml/2006/main">
               <a:ext uri="{FF2B5EF4-FFF2-40B4-BE49-F238E27FC236}">
-                <a16:creationId xmlns:a16="http://schemas.microsoft.com/office/drawing/2014/main" id="{B9807236-A624-46F4-AAE2-1B6AF357D568}"/>
+                <a16:creationId xmlns:a16="http://schemas.microsoft.com/office/drawing/2014/main" id="{93F1CE8A-127F-4D91-918C-2498F8149B55}"/>
               </a:ext>
             </a:extLst>
           </p:cNvPr>
@@ -1544,7 +1544,7 @@
           <p:cNvPr id="2" name="">
             <a:extLst xmlns:a="http://schemas.openxmlformats.org/drawingml/2006/main">
               <a:ext uri="{FF2B5EF4-FFF2-40B4-BE49-F238E27FC236}">
-                <a16:creationId xmlns:a16="http://schemas.microsoft.com/office/drawing/2014/main" id="{B4C4A2B3-D267-49C1-839A-C3896196B080}"/>
+                <a16:creationId xmlns:a16="http://schemas.microsoft.com/office/drawing/2014/main" id="{6C344DFB-963B-4544-8BED-1D7A6EDC7F83}"/>
               </a:ext>
             </a:extLst>
           </p:cNvPr>
@@ -1574,7 +1574,7 @@
           <p:cNvPr id="3" name="">
             <a:extLst xmlns:a="http://schemas.openxmlformats.org/drawingml/2006/main">
               <a:ext uri="{FF2B5EF4-FFF2-40B4-BE49-F238E27FC236}">
-                <a16:creationId xmlns:a16="http://schemas.microsoft.com/office/drawing/2014/main" id="{57C26B42-533D-416D-A25C-6DE3ECA0A77E}"/>
+                <a16:creationId xmlns:a16="http://schemas.microsoft.com/office/drawing/2014/main" id="{BEA3402F-8828-47BC-B9DA-60EFC689A1DC}"/>
               </a:ext>
             </a:extLst>
           </p:cNvPr>
@@ -1631,7 +1631,7 @@
           <p:cNvPr id="4" name="">
             <a:extLst xmlns:a="http://schemas.openxmlformats.org/drawingml/2006/main">
               <a:ext uri="{FF2B5EF4-FFF2-40B4-BE49-F238E27FC236}">
-                <a16:creationId xmlns:a16="http://schemas.microsoft.com/office/drawing/2014/main" id="{770977F4-E103-4E54-BAFD-191B6191E6F0}"/>
+                <a16:creationId xmlns:a16="http://schemas.microsoft.com/office/drawing/2014/main" id="{868DCE48-FD1B-4E26-BBA1-52EE17234819}"/>
               </a:ext>
             </a:extLst>
           </p:cNvPr>
@@ -1688,7 +1688,7 @@
           <p:cNvPr id="5" name="">
             <a:extLst xmlns:a="http://schemas.openxmlformats.org/drawingml/2006/main">
               <a:ext uri="{FF2B5EF4-FFF2-40B4-BE49-F238E27FC236}">
-                <a16:creationId xmlns:a16="http://schemas.microsoft.com/office/drawing/2014/main" id="{5AD8D6AA-E32E-45E2-8AFF-1CA5A35CDE9A}"/>
+                <a16:creationId xmlns:a16="http://schemas.microsoft.com/office/drawing/2014/main" id="{D26544DE-FC23-4CC0-812F-651CA18EEC1B}"/>
               </a:ext>
             </a:extLst>
           </p:cNvPr>
@@ -1718,7 +1718,7 @@
           <p:cNvPr id="6" name="">
             <a:extLst xmlns:a="http://schemas.openxmlformats.org/drawingml/2006/main">
               <a:ext uri="{FF2B5EF4-FFF2-40B4-BE49-F238E27FC236}">
-                <a16:creationId xmlns:a16="http://schemas.microsoft.com/office/drawing/2014/main" id="{D47FAE39-68C9-410F-AFCA-D1615C705D18}"/>
+                <a16:creationId xmlns:a16="http://schemas.microsoft.com/office/drawing/2014/main" id="{5F790780-56F7-466A-9554-A0CEE447B78C}"/>
               </a:ext>
             </a:extLst>
           </p:cNvPr>
@@ -1775,7 +1775,7 @@
           <p:cNvPr id="7" name="">
             <a:extLst xmlns:a="http://schemas.openxmlformats.org/drawingml/2006/main">
               <a:ext uri="{FF2B5EF4-FFF2-40B4-BE49-F238E27FC236}">
-                <a16:creationId xmlns:a16="http://schemas.microsoft.com/office/drawing/2014/main" id="{405D9FC7-25E8-430E-BDB8-007F76DEDE96}"/>
+                <a16:creationId xmlns:a16="http://schemas.microsoft.com/office/drawing/2014/main" id="{291EFE50-3190-42A3-870C-01AC1B116FC5}"/>
               </a:ext>
             </a:extLst>
           </p:cNvPr>
@@ -1832,7 +1832,7 @@
           <p:cNvPr id="8" name="">
             <a:extLst xmlns:a="http://schemas.openxmlformats.org/drawingml/2006/main">
               <a:ext uri="{FF2B5EF4-FFF2-40B4-BE49-F238E27FC236}">
-                <a16:creationId xmlns:a16="http://schemas.microsoft.com/office/drawing/2014/main" id="{0C34E49A-80D0-4996-8CCB-60746EC22C25}"/>
+                <a16:creationId xmlns:a16="http://schemas.microsoft.com/office/drawing/2014/main" id="{9FDDDDCE-B2B5-4485-A569-75ABAF0565AD}"/>
               </a:ext>
             </a:extLst>
           </p:cNvPr>
@@ -1889,7 +1889,7 @@
           <p:cNvPr id="9" name="">
             <a:extLst xmlns:a="http://schemas.openxmlformats.org/drawingml/2006/main">
               <a:ext uri="{FF2B5EF4-FFF2-40B4-BE49-F238E27FC236}">
-                <a16:creationId xmlns:a16="http://schemas.microsoft.com/office/drawing/2014/main" id="{57FCB5F5-5142-497D-B26A-74308764EB4E}"/>
+                <a16:creationId xmlns:a16="http://schemas.microsoft.com/office/drawing/2014/main" id="{1C0EE509-4458-4A82-9A8F-D454C019659C}"/>
               </a:ext>
             </a:extLst>
           </p:cNvPr>
@@ -1946,7 +1946,7 @@
           <p:cNvPr id="10" name="">
             <a:extLst xmlns:a="http://schemas.openxmlformats.org/drawingml/2006/main">
               <a:ext uri="{FF2B5EF4-FFF2-40B4-BE49-F238E27FC236}">
-                <a16:creationId xmlns:a16="http://schemas.microsoft.com/office/drawing/2014/main" id="{B93612EA-1B03-43A3-A1B0-02500B21FFEF}"/>
+                <a16:creationId xmlns:a16="http://schemas.microsoft.com/office/drawing/2014/main" id="{8BBDA143-25F9-4EAF-8F8B-2387265CACFE}"/>
               </a:ext>
             </a:extLst>
           </p:cNvPr>
@@ -1980,7 +1980,7 @@
           <p:cNvPr id="11" name="">
             <a:extLst xmlns:a="http://schemas.openxmlformats.org/drawingml/2006/main">
               <a:ext uri="{FF2B5EF4-FFF2-40B4-BE49-F238E27FC236}">
-                <a16:creationId xmlns:a16="http://schemas.microsoft.com/office/drawing/2014/main" id="{D4AECBAE-65D5-43F6-8705-F483C4C9FFF3}"/>
+                <a16:creationId xmlns:a16="http://schemas.microsoft.com/office/drawing/2014/main" id="{84237294-5EE4-476E-9480-DA89BFE0E5E9}"/>
               </a:ext>
             </a:extLst>
           </p:cNvPr>
@@ -2037,7 +2037,7 @@
           <p:cNvPr id="12" name="">
             <a:extLst xmlns:a="http://schemas.openxmlformats.org/drawingml/2006/main">
               <a:ext uri="{FF2B5EF4-FFF2-40B4-BE49-F238E27FC236}">
-                <a16:creationId xmlns:a16="http://schemas.microsoft.com/office/drawing/2014/main" id="{5DF52D42-DDDD-4AC4-834E-570E1DE9DB0A}"/>
+                <a16:creationId xmlns:a16="http://schemas.microsoft.com/office/drawing/2014/main" id="{2FEFB8A1-5D38-40C6-8C6A-20B3E11429A7}"/>
               </a:ext>
             </a:extLst>
           </p:cNvPr>
@@ -2071,7 +2071,7 @@
           <p:cNvPr id="13" name="">
             <a:extLst xmlns:a="http://schemas.openxmlformats.org/drawingml/2006/main">
               <a:ext uri="{FF2B5EF4-FFF2-40B4-BE49-F238E27FC236}">
-                <a16:creationId xmlns:a16="http://schemas.microsoft.com/office/drawing/2014/main" id="{C9103723-CAF0-44A2-BD32-F41311823C91}"/>
+                <a16:creationId xmlns:a16="http://schemas.microsoft.com/office/drawing/2014/main" id="{2F437A67-DB1A-4B88-890E-606CD7232839}"/>
               </a:ext>
             </a:extLst>
           </p:cNvPr>
@@ -2128,7 +2128,7 @@
           <p:cNvPr id="14" name="">
             <a:extLst xmlns:a="http://schemas.openxmlformats.org/drawingml/2006/main">
               <a:ext uri="{FF2B5EF4-FFF2-40B4-BE49-F238E27FC236}">
-                <a16:creationId xmlns:a16="http://schemas.microsoft.com/office/drawing/2014/main" id="{3D71813B-B644-4C3C-A6DE-32B40082D0D6}"/>
+                <a16:creationId xmlns:a16="http://schemas.microsoft.com/office/drawing/2014/main" id="{B6F811F3-7EBE-40E7-8C36-F2C8A0F9E854}"/>
               </a:ext>
             </a:extLst>
           </p:cNvPr>
@@ -2162,7 +2162,7 @@
           <p:cNvPr id="15" name="">
             <a:extLst xmlns:a="http://schemas.openxmlformats.org/drawingml/2006/main">
               <a:ext uri="{FF2B5EF4-FFF2-40B4-BE49-F238E27FC236}">
-                <a16:creationId xmlns:a16="http://schemas.microsoft.com/office/drawing/2014/main" id="{E82D286B-D86F-4CD1-AC79-E48E96F134D1}"/>
+                <a16:creationId xmlns:a16="http://schemas.microsoft.com/office/drawing/2014/main" id="{AF246B37-638E-4E3C-9160-4DF635B3F394}"/>
               </a:ext>
             </a:extLst>
           </p:cNvPr>
@@ -2219,7 +2219,7 @@
           <p:cNvPr id="16" name="">
             <a:extLst xmlns:a="http://schemas.openxmlformats.org/drawingml/2006/main">
               <a:ext uri="{FF2B5EF4-FFF2-40B4-BE49-F238E27FC236}">
-                <a16:creationId xmlns:a16="http://schemas.microsoft.com/office/drawing/2014/main" id="{2FB8F05B-C50F-4F70-828A-3FD4B807E900}"/>
+                <a16:creationId xmlns:a16="http://schemas.microsoft.com/office/drawing/2014/main" id="{B1F910EA-C5A1-49F4-82B8-22E9CD441D2F}"/>
               </a:ext>
             </a:extLst>
           </p:cNvPr>
@@ -2276,7 +2276,7 @@
           <p:cNvPr id="17" name="">
             <a:extLst xmlns:a="http://schemas.openxmlformats.org/drawingml/2006/main">
               <a:ext uri="{FF2B5EF4-FFF2-40B4-BE49-F238E27FC236}">
-                <a16:creationId xmlns:a16="http://schemas.microsoft.com/office/drawing/2014/main" id="{68C5E843-9D95-4B57-BB7B-EE90B90B417A}"/>
+                <a16:creationId xmlns:a16="http://schemas.microsoft.com/office/drawing/2014/main" id="{05F21881-3150-498C-988C-153AB158B52A}"/>
               </a:ext>
             </a:extLst>
           </p:cNvPr>
@@ -2333,7 +2333,7 @@
           <p:cNvPr id="18" name="">
             <a:extLst xmlns:a="http://schemas.openxmlformats.org/drawingml/2006/main">
               <a:ext uri="{FF2B5EF4-FFF2-40B4-BE49-F238E27FC236}">
-                <a16:creationId xmlns:a16="http://schemas.microsoft.com/office/drawing/2014/main" id="{CD5F30F6-022E-4477-93CA-594545749FC5}"/>
+                <a16:creationId xmlns:a16="http://schemas.microsoft.com/office/drawing/2014/main" id="{0E7F0602-E483-4C7F-9839-0954C986EC07}"/>
               </a:ext>
             </a:extLst>
           </p:cNvPr>
@@ -2390,7 +2390,7 @@
           <p:cNvPr id="19" name="">
             <a:extLst xmlns:a="http://schemas.openxmlformats.org/drawingml/2006/main">
               <a:ext uri="{FF2B5EF4-FFF2-40B4-BE49-F238E27FC236}">
-                <a16:creationId xmlns:a16="http://schemas.microsoft.com/office/drawing/2014/main" id="{D05E1616-C1F3-40F0-908D-66AD69B58BD3}"/>
+                <a16:creationId xmlns:a16="http://schemas.microsoft.com/office/drawing/2014/main" id="{BF5F1AA7-ACEB-438C-8AEA-3FB9EA658029}"/>
               </a:ext>
             </a:extLst>
           </p:cNvPr>
@@ -2420,7 +2420,7 @@
           <p:cNvPr id="20" name="">
             <a:extLst xmlns:a="http://schemas.openxmlformats.org/drawingml/2006/main">
               <a:ext uri="{FF2B5EF4-FFF2-40B4-BE49-F238E27FC236}">
-                <a16:creationId xmlns:a16="http://schemas.microsoft.com/office/drawing/2014/main" id="{C9919EB1-A0AD-42BE-9085-28F2259A3A7B}"/>
+                <a16:creationId xmlns:a16="http://schemas.microsoft.com/office/drawing/2014/main" id="{99076E18-C639-47D6-A204-4A1767339240}"/>
               </a:ext>
             </a:extLst>
           </p:cNvPr>
@@ -2450,7 +2450,7 @@
           <p:cNvPr id="21" name="">
             <a:extLst xmlns:a="http://schemas.openxmlformats.org/drawingml/2006/main">
               <a:ext uri="{FF2B5EF4-FFF2-40B4-BE49-F238E27FC236}">
-                <a16:creationId xmlns:a16="http://schemas.microsoft.com/office/drawing/2014/main" id="{257DA396-0655-47F4-BC1A-12EBC8B96BCB}"/>
+                <a16:creationId xmlns:a16="http://schemas.microsoft.com/office/drawing/2014/main" id="{099E66BD-C0AC-4090-B763-76B3BC5BDAAC}"/>
               </a:ext>
             </a:extLst>
           </p:cNvPr>
@@ -2480,7 +2480,7 @@
           <p:cNvPr id="22" name="">
             <a:extLst xmlns:a="http://schemas.openxmlformats.org/drawingml/2006/main">
               <a:ext uri="{FF2B5EF4-FFF2-40B4-BE49-F238E27FC236}">
-                <a16:creationId xmlns:a16="http://schemas.microsoft.com/office/drawing/2014/main" id="{4F31888D-65A9-4F9F-9808-3A28F833AFCE}"/>
+                <a16:creationId xmlns:a16="http://schemas.microsoft.com/office/drawing/2014/main" id="{A1D9A70A-5FB2-41CB-8C17-4BCEE79CE487}"/>
               </a:ext>
             </a:extLst>
           </p:cNvPr>
@@ -2510,7 +2510,7 @@
           <p:cNvPr id="23" name="">
             <a:extLst xmlns:a="http://schemas.openxmlformats.org/drawingml/2006/main">
               <a:ext uri="{FF2B5EF4-FFF2-40B4-BE49-F238E27FC236}">
-                <a16:creationId xmlns:a16="http://schemas.microsoft.com/office/drawing/2014/main" id="{54AA4B10-4E10-4A5D-965E-5879DACF7B96}"/>
+                <a16:creationId xmlns:a16="http://schemas.microsoft.com/office/drawing/2014/main" id="{52E0FBB4-FAA3-4E80-AB12-3DC5EB41B9C7}"/>
               </a:ext>
             </a:extLst>
           </p:cNvPr>
@@ -2542,7 +2542,7 @@
           <p:cNvPr id="24" name="">
             <a:extLst xmlns:a="http://schemas.openxmlformats.org/drawingml/2006/main">
               <a:ext uri="{FF2B5EF4-FFF2-40B4-BE49-F238E27FC236}">
-                <a16:creationId xmlns:a16="http://schemas.microsoft.com/office/drawing/2014/main" id="{C5A6216A-0A58-413E-942E-3248FBB558FC}"/>
+                <a16:creationId xmlns:a16="http://schemas.microsoft.com/office/drawing/2014/main" id="{114F9CD8-433F-48E0-876C-0C4864512575}"/>
               </a:ext>
             </a:extLst>
           </p:cNvPr>
@@ -2574,7 +2574,7 @@
           <p:cNvPr id="25" name="">
             <a:extLst xmlns:a="http://schemas.openxmlformats.org/drawingml/2006/main">
               <a:ext uri="{FF2B5EF4-FFF2-40B4-BE49-F238E27FC236}">
-                <a16:creationId xmlns:a16="http://schemas.microsoft.com/office/drawing/2014/main" id="{B09E36B6-6E06-48DF-86C4-8D23C662D53B}"/>
+                <a16:creationId xmlns:a16="http://schemas.microsoft.com/office/drawing/2014/main" id="{79C0F0D1-3A94-47C7-A822-01527389DCF8}"/>
               </a:ext>
             </a:extLst>
           </p:cNvPr>
@@ -2606,7 +2606,7 @@
           <p:cNvPr id="26" name="">
             <a:extLst xmlns:a="http://schemas.openxmlformats.org/drawingml/2006/main">
               <a:ext uri="{FF2B5EF4-FFF2-40B4-BE49-F238E27FC236}">
-                <a16:creationId xmlns:a16="http://schemas.microsoft.com/office/drawing/2014/main" id="{38346850-3D38-49EF-871C-48DDAC5859DD}"/>
+                <a16:creationId xmlns:a16="http://schemas.microsoft.com/office/drawing/2014/main" id="{E73268FF-C93C-4A26-9084-30793D19886D}"/>
               </a:ext>
             </a:extLst>
           </p:cNvPr>
@@ -2638,7 +2638,7 @@
           <p:cNvPr id="27" name="">
             <a:extLst xmlns:a="http://schemas.openxmlformats.org/drawingml/2006/main">
               <a:ext uri="{FF2B5EF4-FFF2-40B4-BE49-F238E27FC236}">
-                <a16:creationId xmlns:a16="http://schemas.microsoft.com/office/drawing/2014/main" id="{389434E2-C1F4-4E8C-BD6D-586AC5915DDC}"/>
+                <a16:creationId xmlns:a16="http://schemas.microsoft.com/office/drawing/2014/main" id="{EDF3D03A-DC1E-4DC9-B1ED-9C3B57AA3EC7}"/>
               </a:ext>
             </a:extLst>
           </p:cNvPr>
@@ -2670,7 +2670,7 @@
           <p:cNvPr id="28" name="">
             <a:extLst xmlns:a="http://schemas.openxmlformats.org/drawingml/2006/main">
               <a:ext uri="{FF2B5EF4-FFF2-40B4-BE49-F238E27FC236}">
-                <a16:creationId xmlns:a16="http://schemas.microsoft.com/office/drawing/2014/main" id="{8C5E1DDF-B1E9-48B9-9838-4DC78CC8AB2C}"/>
+                <a16:creationId xmlns:a16="http://schemas.microsoft.com/office/drawing/2014/main" id="{7565E4F0-16CD-40CE-8188-D3E2860853A1}"/>
               </a:ext>
             </a:extLst>
           </p:cNvPr>
@@ -2725,7 +2725,7 @@
     </p:spTree>
     <p:extLst>
       <p:ext uri="{BB962C8B-B14F-4D97-AF65-F5344CB8AC3E}">
-        <p14:creationId xmlns:p14="http://schemas.microsoft.com/office/powerpoint/2010/main" val="88255965"/>
+        <p14:creationId xmlns:p14="http://schemas.microsoft.com/office/powerpoint/2010/main" val="1050329291"/>
       </p:ext>
     </p:extLst>
   </p:cSld>
@@ -2753,10 +2753,10 @@
       </p:grpSpPr>
       <p:sp>
         <p:nvSpPr>
-          <p:cNvPr id="26" name="">
-            <a:extLst xmlns:a="http://schemas.openxmlformats.org/drawingml/2006/main">
-              <a:ext uri="{FF2B5EF4-FFF2-40B4-BE49-F238E27FC236}">
-                <a16:creationId xmlns:a16="http://schemas.microsoft.com/office/drawing/2014/main" id="{3EBA7A36-FC7B-457C-ABF7-C60B5347ED76}"/>
+          <p:cNvPr id="29" name="">
+            <a:extLst xmlns:a="http://schemas.openxmlformats.org/drawingml/2006/main">
+              <a:ext uri="{FF2B5EF4-FFF2-40B4-BE49-F238E27FC236}">
+                <a16:creationId xmlns:a16="http://schemas.microsoft.com/office/drawing/2014/main" id="{0DE5EEBA-28EE-414D-A6BC-87BD12B9DEDE}"/>
               </a:ext>
             </a:extLst>
           </p:cNvPr>
@@ -2813,7 +2813,7 @@
           <p:cNvPr id="2" name="">
             <a:extLst xmlns:a="http://schemas.openxmlformats.org/drawingml/2006/main">
               <a:ext uri="{FF2B5EF4-FFF2-40B4-BE49-F238E27FC236}">
-                <a16:creationId xmlns:a16="http://schemas.microsoft.com/office/drawing/2014/main" id="{827ED705-00F0-4801-8EB9-A9AD26C4BB5E}"/>
+                <a16:creationId xmlns:a16="http://schemas.microsoft.com/office/drawing/2014/main" id="{C024D202-6637-47C7-AA89-792CFB2750A3}"/>
               </a:ext>
             </a:extLst>
           </p:cNvPr>
@@ -2843,7 +2843,7 @@
           <p:cNvPr id="3" name="">
             <a:extLst xmlns:a="http://schemas.openxmlformats.org/drawingml/2006/main">
               <a:ext uri="{FF2B5EF4-FFF2-40B4-BE49-F238E27FC236}">
-                <a16:creationId xmlns:a16="http://schemas.microsoft.com/office/drawing/2014/main" id="{646A398B-AB43-427B-9818-8F23F5D31A55}"/>
+                <a16:creationId xmlns:a16="http://schemas.microsoft.com/office/drawing/2014/main" id="{0E92E256-A223-4355-8325-3D6FF896FA0E}"/>
               </a:ext>
             </a:extLst>
           </p:cNvPr>
@@ -2900,7 +2900,7 @@
           <p:cNvPr id="4" name="">
             <a:extLst xmlns:a="http://schemas.openxmlformats.org/drawingml/2006/main">
               <a:ext uri="{FF2B5EF4-FFF2-40B4-BE49-F238E27FC236}">
-                <a16:creationId xmlns:a16="http://schemas.microsoft.com/office/drawing/2014/main" id="{69698D2A-9472-4657-8089-B6B96A5489E5}"/>
+                <a16:creationId xmlns:a16="http://schemas.microsoft.com/office/drawing/2014/main" id="{BAAD323C-A37E-4607-97F9-FE4608966A7B}"/>
               </a:ext>
             </a:extLst>
           </p:cNvPr>
@@ -2957,7 +2957,7 @@
           <p:cNvPr id="5" name="">
             <a:extLst xmlns:a="http://schemas.openxmlformats.org/drawingml/2006/main">
               <a:ext uri="{FF2B5EF4-FFF2-40B4-BE49-F238E27FC236}">
-                <a16:creationId xmlns:a16="http://schemas.microsoft.com/office/drawing/2014/main" id="{80E97E1B-2762-4D20-950A-770F53FAB71A}"/>
+                <a16:creationId xmlns:a16="http://schemas.microsoft.com/office/drawing/2014/main" id="{D1CE4E3A-0780-4EC3-858F-E4DB472BDD13}"/>
               </a:ext>
             </a:extLst>
           </p:cNvPr>
@@ -2987,7 +2987,7 @@
           <p:cNvPr id="6" name="">
             <a:extLst xmlns:a="http://schemas.openxmlformats.org/drawingml/2006/main">
               <a:ext uri="{FF2B5EF4-FFF2-40B4-BE49-F238E27FC236}">
-                <a16:creationId xmlns:a16="http://schemas.microsoft.com/office/drawing/2014/main" id="{F76F2DB8-A98B-440B-83F3-B9C6662F93F0}"/>
+                <a16:creationId xmlns:a16="http://schemas.microsoft.com/office/drawing/2014/main" id="{42B30C1A-4C95-497D-A0ED-AA90761134C7}"/>
               </a:ext>
             </a:extLst>
           </p:cNvPr>
@@ -3044,7 +3044,7 @@
           <p:cNvPr id="7" name="">
             <a:extLst xmlns:a="http://schemas.openxmlformats.org/drawingml/2006/main">
               <a:ext uri="{FF2B5EF4-FFF2-40B4-BE49-F238E27FC236}">
-                <a16:creationId xmlns:a16="http://schemas.microsoft.com/office/drawing/2014/main" id="{19FB3F40-E242-42F3-82BA-0F7090F0434D}"/>
+                <a16:creationId xmlns:a16="http://schemas.microsoft.com/office/drawing/2014/main" id="{539A4A65-44C8-4DA1-9416-60842FF697BF}"/>
               </a:ext>
             </a:extLst>
           </p:cNvPr>
@@ -3101,7 +3101,7 @@
           <p:cNvPr id="8" name="">
             <a:extLst xmlns:a="http://schemas.openxmlformats.org/drawingml/2006/main">
               <a:ext uri="{FF2B5EF4-FFF2-40B4-BE49-F238E27FC236}">
-                <a16:creationId xmlns:a16="http://schemas.microsoft.com/office/drawing/2014/main" id="{C4339756-D3FD-4C76-8BC8-32063BE01FA1}"/>
+                <a16:creationId xmlns:a16="http://schemas.microsoft.com/office/drawing/2014/main" id="{B12B84C8-AE30-4BE2-AEDA-D07158934093}"/>
               </a:ext>
             </a:extLst>
           </p:cNvPr>
@@ -3158,7 +3158,7 @@
           <p:cNvPr id="9" name="">
             <a:extLst xmlns:a="http://schemas.openxmlformats.org/drawingml/2006/main">
               <a:ext uri="{FF2B5EF4-FFF2-40B4-BE49-F238E27FC236}">
-                <a16:creationId xmlns:a16="http://schemas.microsoft.com/office/drawing/2014/main" id="{543D26D1-8809-43FF-BCE7-14BB5BECDC70}"/>
+                <a16:creationId xmlns:a16="http://schemas.microsoft.com/office/drawing/2014/main" id="{86E468F6-0614-4D53-9C02-AA27997CE1F7}"/>
               </a:ext>
             </a:extLst>
           </p:cNvPr>
@@ -3215,7 +3215,7 @@
           <p:cNvPr id="10" name="">
             <a:extLst xmlns:a="http://schemas.openxmlformats.org/drawingml/2006/main">
               <a:ext uri="{FF2B5EF4-FFF2-40B4-BE49-F238E27FC236}">
-                <a16:creationId xmlns:a16="http://schemas.microsoft.com/office/drawing/2014/main" id="{F5B41D9D-7E27-4C91-ACB2-2D236C4DF4DC}"/>
+                <a16:creationId xmlns:a16="http://schemas.microsoft.com/office/drawing/2014/main" id="{72B31283-2864-4A19-9C87-1BF11532D74A}"/>
               </a:ext>
             </a:extLst>
           </p:cNvPr>
@@ -3249,7 +3249,7 @@
           <p:cNvPr id="11" name="">
             <a:extLst xmlns:a="http://schemas.openxmlformats.org/drawingml/2006/main">
               <a:ext uri="{FF2B5EF4-FFF2-40B4-BE49-F238E27FC236}">
-                <a16:creationId xmlns:a16="http://schemas.microsoft.com/office/drawing/2014/main" id="{D315171D-2BAD-4FD4-B06C-E67480D9CCA8}"/>
+                <a16:creationId xmlns:a16="http://schemas.microsoft.com/office/drawing/2014/main" id="{F035F1A9-D1E5-4D5A-834F-05830DD7E058}"/>
               </a:ext>
             </a:extLst>
           </p:cNvPr>
@@ -3306,7 +3306,7 @@
           <p:cNvPr id="12" name="">
             <a:extLst xmlns:a="http://schemas.openxmlformats.org/drawingml/2006/main">
               <a:ext uri="{FF2B5EF4-FFF2-40B4-BE49-F238E27FC236}">
-                <a16:creationId xmlns:a16="http://schemas.microsoft.com/office/drawing/2014/main" id="{79D29FA0-37F4-4C65-B3AF-FDA41153C00C}"/>
+                <a16:creationId xmlns:a16="http://schemas.microsoft.com/office/drawing/2014/main" id="{F5264DE0-DBA2-4AFD-B9E6-A0C4C16B4934}"/>
               </a:ext>
             </a:extLst>
           </p:cNvPr>
@@ -3356,29 +3356,6 @@
               <a:t>on a busy day</a:t>
             </a:r>
           </a:p>
-          <a:p xmlns:a="http://schemas.openxmlformats.org/drawingml/2006/main">
-            <a:pPr>
-              <a:defRPr sz="1350" b="0">
-                <a:solidFill>
-                  <a:srgbClr val="59635E"/>
-                </a:solidFill>
-                <a:latin typeface="Arial"/>
-                <a:ea typeface="Arial"/>
-                <a:cs typeface="Arial"/>
-              </a:defRPr>
-            </a:pPr>
-            <a:r>
-              <a:rPr sz="1350" b="0">
-                <a:solidFill>
-                  <a:srgbClr val="59635E"/>
-                </a:solidFill>
-                <a:latin typeface="Arial"/>
-                <a:ea typeface="Arial"/>
-                <a:cs typeface="Arial"/>
-              </a:rPr>
-              <a:t>interview reported</a:t>
-            </a:r>
-          </a:p>
         </p:txBody>
       </p:sp>
       <p:sp>
@@ -3386,7 +3363,7 @@
           <p:cNvPr id="13" name="">
             <a:extLst xmlns:a="http://schemas.openxmlformats.org/drawingml/2006/main">
               <a:ext uri="{FF2B5EF4-FFF2-40B4-BE49-F238E27FC236}">
-                <a16:creationId xmlns:a16="http://schemas.microsoft.com/office/drawing/2014/main" id="{DBCD3EE5-6816-46AB-AB94-750B07C7B23C}"/>
+                <a16:creationId xmlns:a16="http://schemas.microsoft.com/office/drawing/2014/main" id="{AF369418-7164-4882-B05E-1E387B879DF7}"/>
               </a:ext>
             </a:extLst>
           </p:cNvPr>
@@ -3443,7 +3420,7 @@
           <p:cNvPr id="14" name="">
             <a:extLst xmlns:a="http://schemas.openxmlformats.org/drawingml/2006/main">
               <a:ext uri="{FF2B5EF4-FFF2-40B4-BE49-F238E27FC236}">
-                <a16:creationId xmlns:a16="http://schemas.microsoft.com/office/drawing/2014/main" id="{CA2CAA8A-C9E0-456D-BB0F-4D78476B2BC3}"/>
+                <a16:creationId xmlns:a16="http://schemas.microsoft.com/office/drawing/2014/main" id="{B0690473-B17A-4F2B-BDB3-1DC86A39978E}"/>
               </a:ext>
             </a:extLst>
           </p:cNvPr>
@@ -3477,19 +3454,79 @@
           <p:cNvPr id="15" name="">
             <a:extLst xmlns:a="http://schemas.openxmlformats.org/drawingml/2006/main">
               <a:ext uri="{FF2B5EF4-FFF2-40B4-BE49-F238E27FC236}">
-                <a16:creationId xmlns:a16="http://schemas.microsoft.com/office/drawing/2014/main" id="{D979AAC4-7E94-4F79-8EDA-CB3783F46474}"/>
-              </a:ext>
-            </a:extLst>
-          </p:cNvPr>
-          <p:cNvSpPr>
-            <a:spLocks xmlns:a="http://schemas.openxmlformats.org/drawingml/2006/main" noGrp="1"/>
-          </p:cNvSpPr>
-          <p:nvPr/>
-        </p:nvSpPr>
-        <p:spPr>
-          <a:xfrm xmlns:a="http://schemas.openxmlformats.org/drawingml/2006/main">
-            <a:off x="3829050" y="2609850"/>
-            <a:ext cx="2286000" cy="323850"/>
+                <a16:creationId xmlns:a16="http://schemas.microsoft.com/office/drawing/2014/main" id="{787A1D3C-6426-4E1F-9545-DD3E068A64CB}"/>
+              </a:ext>
+            </a:extLst>
+          </p:cNvPr>
+          <p:cNvSpPr>
+            <a:spLocks xmlns:a="http://schemas.openxmlformats.org/drawingml/2006/main" noGrp="1"/>
+          </p:cNvSpPr>
+          <p:nvPr/>
+        </p:nvSpPr>
+        <p:spPr>
+          <a:xfrm xmlns:a="http://schemas.openxmlformats.org/drawingml/2006/main">
+            <a:off x="3838575" y="2609850"/>
+            <a:ext cx="323850" cy="323850"/>
+          </a:xfrm>
+          <a:prstGeom xmlns:a="http://schemas.openxmlformats.org/drawingml/2006/main" prst="ellipse">
+            <a:avLst/>
+          </a:prstGeom>
+          <a:solidFill xmlns:a="http://schemas.openxmlformats.org/drawingml/2006/main">
+            <a:srgbClr val="25D366"/>
+          </a:solidFill>
+          <a:ln xmlns:a="http://schemas.openxmlformats.org/drawingml/2006/main" w="0">
+            <a:solidFill>
+              <a:srgbClr val="25D366"/>
+            </a:solidFill>
+          </a:ln>
+        </p:spPr>
+      </p:sp>
+      <p:pic>
+        <p:nvPicPr>
+          <p:cNvPr id="44" name=""/>
+          <p:cNvPicPr>
+            <a:picLocks xmlns:a="http://schemas.openxmlformats.org/drawingml/2006/main" noChangeAspect="1"/>
+          </p:cNvPicPr>
+          <p:nvPr/>
+        </p:nvPicPr>
+        <p:blipFill>
+          <a:blip xmlns:r="http://schemas.openxmlformats.org/officeDocument/2006/relationships" xmlns:a="http://schemas.openxmlformats.org/drawingml/2006/main" r:embed="R0769144cdba04a84">
+            <a:extLst>
+              <a:ext uri="{96DAC541-7B7A-43D3-8B79-37D633B846F1}">
+                <asvg:svgBlip xmlns:asvg="http://schemas.microsoft.com/office/drawing/2016/SVG/main" r:embed="Ra022c717ccbe48ab"/>
+              </a:ext>
+            </a:extLst>
+          </a:blip>
+          <a:stretch xmlns:a="http://schemas.openxmlformats.org/drawingml/2006/main"/>
+        </p:blipFill>
+        <p:spPr>
+          <a:xfrm xmlns:a="http://schemas.openxmlformats.org/drawingml/2006/main">
+            <a:off x="3895725" y="2667000"/>
+            <a:ext cx="209550" cy="209550"/>
+          </a:xfrm>
+          <a:prstGeom xmlns:a="http://schemas.openxmlformats.org/drawingml/2006/main" prst="rect">
+            <a:avLst/>
+          </a:prstGeom>
+        </p:spPr>
+      </p:pic>
+      <p:sp>
+        <p:nvSpPr>
+          <p:cNvPr id="17" name="">
+            <a:extLst xmlns:a="http://schemas.openxmlformats.org/drawingml/2006/main">
+              <a:ext uri="{FF2B5EF4-FFF2-40B4-BE49-F238E27FC236}">
+                <a16:creationId xmlns:a16="http://schemas.microsoft.com/office/drawing/2014/main" id="{4B6744EF-07DB-4693-B038-4288878C7F8D}"/>
+              </a:ext>
+            </a:extLst>
+          </p:cNvPr>
+          <p:cNvSpPr>
+            <a:spLocks xmlns:a="http://schemas.openxmlformats.org/drawingml/2006/main" noGrp="1"/>
+          </p:cNvSpPr>
+          <p:nvPr/>
+        </p:nvSpPr>
+        <p:spPr>
+          <a:xfrm xmlns:a="http://schemas.openxmlformats.org/drawingml/2006/main">
+            <a:off x="4267200" y="2609850"/>
+            <a:ext cx="1809750" cy="323850"/>
           </a:xfrm>
           <a:prstGeom xmlns:a="http://schemas.openxmlformats.org/drawingml/2006/main" prst="rect">
             <a:avLst/>
@@ -3531,10 +3568,10 @@
       </p:sp>
       <p:sp>
         <p:nvSpPr>
-          <p:cNvPr id="16" name="">
-            <a:extLst xmlns:a="http://schemas.openxmlformats.org/drawingml/2006/main">
-              <a:ext uri="{FF2B5EF4-FFF2-40B4-BE49-F238E27FC236}">
-                <a16:creationId xmlns:a16="http://schemas.microsoft.com/office/drawing/2014/main" id="{82DE00DE-3180-4C93-AB59-7066C4174BE4}"/>
+          <p:cNvPr id="18" name="">
+            <a:extLst xmlns:a="http://schemas.openxmlformats.org/drawingml/2006/main">
+              <a:ext uri="{FF2B5EF4-FFF2-40B4-BE49-F238E27FC236}">
+                <a16:creationId xmlns:a16="http://schemas.microsoft.com/office/drawing/2014/main" id="{7A4E36CA-4AED-48EC-BAC5-A4DC67BCE72A}"/>
               </a:ext>
             </a:extLst>
           </p:cNvPr>
@@ -3611,10 +3648,10 @@
       </p:sp>
       <p:sp>
         <p:nvSpPr>
-          <p:cNvPr id="17" name="">
-            <a:extLst xmlns:a="http://schemas.openxmlformats.org/drawingml/2006/main">
-              <a:ext uri="{FF2B5EF4-FFF2-40B4-BE49-F238E27FC236}">
-                <a16:creationId xmlns:a16="http://schemas.microsoft.com/office/drawing/2014/main" id="{EAFBA945-FAED-4BA8-AD0E-2A8ED6A10CF0}"/>
+          <p:cNvPr id="19" name="">
+            <a:extLst xmlns:a="http://schemas.openxmlformats.org/drawingml/2006/main">
+              <a:ext uri="{FF2B5EF4-FFF2-40B4-BE49-F238E27FC236}">
+                <a16:creationId xmlns:a16="http://schemas.microsoft.com/office/drawing/2014/main" id="{27F05FA4-73A9-4738-8281-CE8CB8BE092F}"/>
               </a:ext>
             </a:extLst>
           </p:cNvPr>
@@ -3668,10 +3705,10 @@
       </p:sp>
       <p:sp>
         <p:nvSpPr>
-          <p:cNvPr id="18" name="">
-            <a:extLst xmlns:a="http://schemas.openxmlformats.org/drawingml/2006/main">
-              <a:ext uri="{FF2B5EF4-FFF2-40B4-BE49-F238E27FC236}">
-                <a16:creationId xmlns:a16="http://schemas.microsoft.com/office/drawing/2014/main" id="{3EA59BE4-1C2C-4020-880B-C2C4E87008DE}"/>
+          <p:cNvPr id="20" name="">
+            <a:extLst xmlns:a="http://schemas.openxmlformats.org/drawingml/2006/main">
+              <a:ext uri="{FF2B5EF4-FFF2-40B4-BE49-F238E27FC236}">
+                <a16:creationId xmlns:a16="http://schemas.microsoft.com/office/drawing/2014/main" id="{6A29C4C8-6F0B-4D33-82B3-60EA069D30D8}"/>
               </a:ext>
             </a:extLst>
           </p:cNvPr>
@@ -3702,10 +3739,10 @@
       </p:sp>
       <p:sp>
         <p:nvSpPr>
-          <p:cNvPr id="19" name="">
-            <a:extLst xmlns:a="http://schemas.openxmlformats.org/drawingml/2006/main">
-              <a:ext uri="{FF2B5EF4-FFF2-40B4-BE49-F238E27FC236}">
-                <a16:creationId xmlns:a16="http://schemas.microsoft.com/office/drawing/2014/main" id="{BF926CB7-EB79-4086-838A-B7E4DEB0C5C7}"/>
+          <p:cNvPr id="21" name="">
+            <a:extLst xmlns:a="http://schemas.openxmlformats.org/drawingml/2006/main">
+              <a:ext uri="{FF2B5EF4-FFF2-40B4-BE49-F238E27FC236}">
+                <a16:creationId xmlns:a16="http://schemas.microsoft.com/office/drawing/2014/main" id="{26327C2A-9412-4E52-827F-108352097E43}"/>
               </a:ext>
             </a:extLst>
           </p:cNvPr>
@@ -3759,10 +3796,10 @@
       </p:sp>
       <p:sp>
         <p:nvSpPr>
-          <p:cNvPr id="20" name="">
-            <a:extLst xmlns:a="http://schemas.openxmlformats.org/drawingml/2006/main">
-              <a:ext uri="{FF2B5EF4-FFF2-40B4-BE49-F238E27FC236}">
-                <a16:creationId xmlns:a16="http://schemas.microsoft.com/office/drawing/2014/main" id="{C70F4BDE-CDAB-4C15-844A-0A26B3094780}"/>
+          <p:cNvPr id="22" name="">
+            <a:extLst xmlns:a="http://schemas.openxmlformats.org/drawingml/2006/main">
+              <a:ext uri="{FF2B5EF4-FFF2-40B4-BE49-F238E27FC236}">
+                <a16:creationId xmlns:a16="http://schemas.microsoft.com/office/drawing/2014/main" id="{6BCA0F57-31F7-4EF4-A340-E4C253F1869A}"/>
               </a:ext>
             </a:extLst>
           </p:cNvPr>
@@ -3839,10 +3876,10 @@
       </p:sp>
       <p:sp>
         <p:nvSpPr>
-          <p:cNvPr id="21" name="">
-            <a:extLst xmlns:a="http://schemas.openxmlformats.org/drawingml/2006/main">
-              <a:ext uri="{FF2B5EF4-FFF2-40B4-BE49-F238E27FC236}">
-                <a16:creationId xmlns:a16="http://schemas.microsoft.com/office/drawing/2014/main" id="{0E95E347-1999-4EAC-A7F8-72C8DD49038F}"/>
+          <p:cNvPr id="23" name="">
+            <a:extLst xmlns:a="http://schemas.openxmlformats.org/drawingml/2006/main">
+              <a:ext uri="{FF2B5EF4-FFF2-40B4-BE49-F238E27FC236}">
+                <a16:creationId xmlns:a16="http://schemas.microsoft.com/office/drawing/2014/main" id="{1995EFAE-EE54-4317-86D2-C130BFF206B7}"/>
               </a:ext>
             </a:extLst>
           </p:cNvPr>
@@ -3873,22 +3910,79 @@
       </p:sp>
       <p:sp>
         <p:nvSpPr>
-          <p:cNvPr id="22" name="">
-            <a:extLst xmlns:a="http://schemas.openxmlformats.org/drawingml/2006/main">
-              <a:ext uri="{FF2B5EF4-FFF2-40B4-BE49-F238E27FC236}">
-                <a16:creationId xmlns:a16="http://schemas.microsoft.com/office/drawing/2014/main" id="{0E64F247-FA34-459F-AA97-646BA8EC5552}"/>
-              </a:ext>
-            </a:extLst>
-          </p:cNvPr>
-          <p:cNvSpPr>
-            <a:spLocks xmlns:a="http://schemas.openxmlformats.org/drawingml/2006/main" noGrp="1"/>
-          </p:cNvSpPr>
-          <p:nvPr/>
-        </p:nvSpPr>
-        <p:spPr>
-          <a:xfrm xmlns:a="http://schemas.openxmlformats.org/drawingml/2006/main">
-            <a:off x="800100" y="4362450"/>
-            <a:ext cx="4857750" cy="781050"/>
+          <p:cNvPr id="24" name="">
+            <a:extLst xmlns:a="http://schemas.openxmlformats.org/drawingml/2006/main">
+              <a:ext uri="{FF2B5EF4-FFF2-40B4-BE49-F238E27FC236}">
+                <a16:creationId xmlns:a16="http://schemas.microsoft.com/office/drawing/2014/main" id="{D394166C-E8DC-4305-B98B-668E59CC3F7D}"/>
+              </a:ext>
+            </a:extLst>
+          </p:cNvPr>
+          <p:cNvSpPr>
+            <a:spLocks xmlns:a="http://schemas.openxmlformats.org/drawingml/2006/main" noGrp="1"/>
+          </p:cNvSpPr>
+          <p:nvPr/>
+        </p:nvSpPr>
+        <p:spPr>
+          <a:xfrm xmlns:a="http://schemas.openxmlformats.org/drawingml/2006/main">
+            <a:off x="800100" y="4324350"/>
+            <a:ext cx="4762500" cy="228600"/>
+          </a:xfrm>
+          <a:prstGeom xmlns:a="http://schemas.openxmlformats.org/drawingml/2006/main" prst="rect">
+            <a:avLst/>
+          </a:prstGeom>
+          <a:noFill xmlns:a="http://schemas.openxmlformats.org/drawingml/2006/main"/>
+          <a:ln xmlns:a="http://schemas.openxmlformats.org/drawingml/2006/main" w="0">
+            <a:noFill/>
+          </a:ln>
+        </p:spPr>
+        <p:txBody>
+          <a:bodyPr xmlns:a="http://schemas.openxmlformats.org/drawingml/2006/main" anchor="ctr">
+            <a:noAutofit/>
+          </a:bodyPr>
+          <a:lstStyle xmlns:a="http://schemas.openxmlformats.org/drawingml/2006/main"/>
+          <a:p xmlns:a="http://schemas.openxmlformats.org/drawingml/2006/main">
+            <a:pPr>
+              <a:defRPr sz="1050" b="1">
+                <a:solidFill>
+                  <a:srgbClr val="237A57"/>
+                </a:solidFill>
+                <a:latin typeface="Arial"/>
+                <a:ea typeface="Arial"/>
+                <a:cs typeface="Arial"/>
+              </a:defRPr>
+            </a:pPr>
+            <a:r>
+              <a:rPr sz="1050" b="1">
+                <a:solidFill>
+                  <a:srgbClr val="237A57"/>
+                </a:solidFill>
+                <a:latin typeface="Arial"/>
+                <a:ea typeface="Arial"/>
+                <a:cs typeface="Arial"/>
+              </a:rPr>
+              <a:t>THE BOTTLENECK</a:t>
+            </a:r>
+          </a:p>
+        </p:txBody>
+      </p:sp>
+      <p:sp>
+        <p:nvSpPr>
+          <p:cNvPr id="25" name="">
+            <a:extLst xmlns:a="http://schemas.openxmlformats.org/drawingml/2006/main">
+              <a:ext uri="{FF2B5EF4-FFF2-40B4-BE49-F238E27FC236}">
+                <a16:creationId xmlns:a16="http://schemas.microsoft.com/office/drawing/2014/main" id="{4B012841-82F7-4BB4-9D8C-5C71B1658AE8}"/>
+              </a:ext>
+            </a:extLst>
+          </p:cNvPr>
+          <p:cNvSpPr>
+            <a:spLocks xmlns:a="http://schemas.openxmlformats.org/drawingml/2006/main" noGrp="1"/>
+          </p:cNvSpPr>
+          <p:nvPr/>
+        </p:nvSpPr>
+        <p:spPr>
+          <a:xfrm xmlns:a="http://schemas.openxmlformats.org/drawingml/2006/main">
+            <a:off x="800100" y="4629150"/>
+            <a:ext cx="4762500" cy="495300"/>
           </a:xfrm>
           <a:prstGeom xmlns:a="http://schemas.openxmlformats.org/drawingml/2006/main" prst="rect">
             <a:avLst/>
@@ -3923,74 +4017,74 @@
                 <a:ea typeface="Georgia"/>
                 <a:cs typeface="Georgia"/>
               </a:rPr>
-              <a:t>“Negotiating customers’ preferred delivery slots is the hardest part.”</a:t>
-            </a:r>
-          </a:p>
-        </p:txBody>
-      </p:sp>
-      <p:sp>
-        <p:nvSpPr>
-          <p:cNvPr id="23" name="">
-            <a:extLst xmlns:a="http://schemas.openxmlformats.org/drawingml/2006/main">
-              <a:ext uri="{FF2B5EF4-FFF2-40B4-BE49-F238E27FC236}">
-                <a16:creationId xmlns:a16="http://schemas.microsoft.com/office/drawing/2014/main" id="{1CD3E406-1EF4-454D-9577-5FB0E8E9CC23}"/>
-              </a:ext>
-            </a:extLst>
-          </p:cNvPr>
-          <p:cNvSpPr>
-            <a:spLocks xmlns:a="http://schemas.openxmlformats.org/drawingml/2006/main" noGrp="1"/>
-          </p:cNvSpPr>
-          <p:nvPr/>
-        </p:nvSpPr>
-        <p:spPr>
-          <a:xfrm xmlns:a="http://schemas.openxmlformats.org/drawingml/2006/main">
-            <a:off x="800100" y="5238750"/>
-            <a:ext cx="4762500" cy="361950"/>
-          </a:xfrm>
-          <a:prstGeom xmlns:a="http://schemas.openxmlformats.org/drawingml/2006/main" prst="rect">
-            <a:avLst/>
-          </a:prstGeom>
-          <a:noFill xmlns:a="http://schemas.openxmlformats.org/drawingml/2006/main"/>
-          <a:ln xmlns:a="http://schemas.openxmlformats.org/drawingml/2006/main" w="0">
-            <a:noFill/>
-          </a:ln>
-        </p:spPr>
-        <p:txBody>
-          <a:bodyPr xmlns:a="http://schemas.openxmlformats.org/drawingml/2006/main" anchor="ctr">
-            <a:noAutofit/>
-          </a:bodyPr>
-          <a:lstStyle xmlns:a="http://schemas.openxmlformats.org/drawingml/2006/main"/>
-          <a:p xmlns:a="http://schemas.openxmlformats.org/drawingml/2006/main">
-            <a:pPr>
-              <a:defRPr sz="1050" b="0">
-                <a:solidFill>
-                  <a:srgbClr val="7E8782"/>
-                </a:solidFill>
-                <a:latin typeface="Arial"/>
-                <a:ea typeface="Arial"/>
-                <a:cs typeface="Arial"/>
-              </a:defRPr>
-            </a:pPr>
-            <a:r>
-              <a:rPr sz="1050" b="0">
-                <a:solidFill>
-                  <a:srgbClr val="7E8782"/>
-                </a:solidFill>
-                <a:latin typeface="Arial"/>
-                <a:ea typeface="Arial"/>
-                <a:cs typeface="Arial"/>
-              </a:rPr>
-              <a:t>Floof.sg interview · 5 September 2026 · paraphrased</a:t>
-            </a:r>
-          </a:p>
-        </p:txBody>
-      </p:sp>
-      <p:sp>
-        <p:nvSpPr>
-          <p:cNvPr id="24" name="">
-            <a:extLst xmlns:a="http://schemas.openxmlformats.org/drawingml/2006/main">
-              <a:ext uri="{FF2B5EF4-FFF2-40B4-BE49-F238E27FC236}">
-                <a16:creationId xmlns:a16="http://schemas.microsoft.com/office/drawing/2014/main" id="{2C26329E-09D6-4934-81B8-624420733ED3}"/>
+              <a:t>Customer availability becomes route input.</a:t>
+            </a:r>
+          </a:p>
+        </p:txBody>
+      </p:sp>
+      <p:sp>
+        <p:nvSpPr>
+          <p:cNvPr id="26" name="">
+            <a:extLst xmlns:a="http://schemas.openxmlformats.org/drawingml/2006/main">
+              <a:ext uri="{FF2B5EF4-FFF2-40B4-BE49-F238E27FC236}">
+                <a16:creationId xmlns:a16="http://schemas.microsoft.com/office/drawing/2014/main" id="{0A77BDEE-FEAA-4C2C-AA4D-D7BB280DFF5D}"/>
+              </a:ext>
+            </a:extLst>
+          </p:cNvPr>
+          <p:cNvSpPr>
+            <a:spLocks xmlns:a="http://schemas.openxmlformats.org/drawingml/2006/main" noGrp="1"/>
+          </p:cNvSpPr>
+          <p:nvPr/>
+        </p:nvSpPr>
+        <p:spPr>
+          <a:xfrm xmlns:a="http://schemas.openxmlformats.org/drawingml/2006/main">
+            <a:off x="800100" y="5219700"/>
+            <a:ext cx="4762500" cy="400050"/>
+          </a:xfrm>
+          <a:prstGeom xmlns:a="http://schemas.openxmlformats.org/drawingml/2006/main" prst="rect">
+            <a:avLst/>
+          </a:prstGeom>
+          <a:noFill xmlns:a="http://schemas.openxmlformats.org/drawingml/2006/main"/>
+          <a:ln xmlns:a="http://schemas.openxmlformats.org/drawingml/2006/main" w="0">
+            <a:noFill/>
+          </a:ln>
+        </p:spPr>
+        <p:txBody>
+          <a:bodyPr xmlns:a="http://schemas.openxmlformats.org/drawingml/2006/main" anchor="t">
+            <a:noAutofit/>
+          </a:bodyPr>
+          <a:lstStyle xmlns:a="http://schemas.openxmlformats.org/drawingml/2006/main"/>
+          <a:p xmlns:a="http://schemas.openxmlformats.org/drawingml/2006/main">
+            <a:pPr>
+              <a:defRPr sz="1275" b="0">
+                <a:solidFill>
+                  <a:srgbClr val="59635E"/>
+                </a:solidFill>
+                <a:latin typeface="Arial"/>
+                <a:ea typeface="Arial"/>
+                <a:cs typeface="Arial"/>
+              </a:defRPr>
+            </a:pPr>
+            <a:r>
+              <a:rPr sz="1275" b="0">
+                <a:solidFill>
+                  <a:srgbClr val="59635E"/>
+                </a:solidFill>
+                <a:latin typeface="Arial"/>
+                <a:ea typeface="Arial"/>
+                <a:cs typeface="Arial"/>
+              </a:rPr>
+              <a:t>One “no” changes both the conversation and the plan.</a:t>
+            </a:r>
+          </a:p>
+        </p:txBody>
+      </p:sp>
+      <p:sp>
+        <p:nvSpPr>
+          <p:cNvPr id="27" name="">
+            <a:extLst xmlns:a="http://schemas.openxmlformats.org/drawingml/2006/main">
+              <a:ext uri="{FF2B5EF4-FFF2-40B4-BE49-F238E27FC236}">
+                <a16:creationId xmlns:a16="http://schemas.microsoft.com/office/drawing/2014/main" id="{7F3DB597-334A-482F-8E22-1DA7002995DE}"/>
               </a:ext>
             </a:extLst>
           </p:cNvPr>
@@ -4044,10 +4138,10 @@
       </p:sp>
       <p:sp>
         <p:nvSpPr>
-          <p:cNvPr id="25" name="">
-            <a:extLst xmlns:a="http://schemas.openxmlformats.org/drawingml/2006/main">
-              <a:ext uri="{FF2B5EF4-FFF2-40B4-BE49-F238E27FC236}">
-                <a16:creationId xmlns:a16="http://schemas.microsoft.com/office/drawing/2014/main" id="{98D82B13-9990-47EC-B958-809C0EB39321}"/>
+          <p:cNvPr id="28" name="">
+            <a:extLst xmlns:a="http://schemas.openxmlformats.org/drawingml/2006/main">
+              <a:ext uri="{FF2B5EF4-FFF2-40B4-BE49-F238E27FC236}">
+                <a16:creationId xmlns:a16="http://schemas.microsoft.com/office/drawing/2014/main" id="{2386D718-A44D-449F-B81F-524FB769AA0E}"/>
               </a:ext>
             </a:extLst>
           </p:cNvPr>
@@ -4102,7 +4196,7 @@
     </p:spTree>
     <p:extLst>
       <p:ext uri="{BB962C8B-B14F-4D97-AF65-F5344CB8AC3E}">
-        <p14:creationId xmlns:p14="http://schemas.microsoft.com/office/powerpoint/2010/main" val="521682899"/>
+        <p14:creationId xmlns:p14="http://schemas.microsoft.com/office/powerpoint/2010/main" val="1264625828"/>
       </p:ext>
     </p:extLst>
   </p:cSld>
@@ -4133,7 +4227,7 @@
           <p:cNvPr id="40" name="">
             <a:extLst xmlns:a="http://schemas.openxmlformats.org/drawingml/2006/main">
               <a:ext uri="{FF2B5EF4-FFF2-40B4-BE49-F238E27FC236}">
-                <a16:creationId xmlns:a16="http://schemas.microsoft.com/office/drawing/2014/main" id="{9CF2B77F-8216-4236-9908-AD90B6819C7E}"/>
+                <a16:creationId xmlns:a16="http://schemas.microsoft.com/office/drawing/2014/main" id="{4418ED09-F13A-44F9-97D7-3815725B47A4}"/>
               </a:ext>
             </a:extLst>
           </p:cNvPr>
@@ -4190,7 +4284,7 @@
           <p:cNvPr id="2" name="">
             <a:extLst xmlns:a="http://schemas.openxmlformats.org/drawingml/2006/main">
               <a:ext uri="{FF2B5EF4-FFF2-40B4-BE49-F238E27FC236}">
-                <a16:creationId xmlns:a16="http://schemas.microsoft.com/office/drawing/2014/main" id="{9F10EC29-00A7-411B-9F51-4D59090835AB}"/>
+                <a16:creationId xmlns:a16="http://schemas.microsoft.com/office/drawing/2014/main" id="{ACACF63C-4933-42DC-946B-44C487FFDA3A}"/>
               </a:ext>
             </a:extLst>
           </p:cNvPr>
@@ -4220,7 +4314,7 @@
           <p:cNvPr id="3" name="">
             <a:extLst xmlns:a="http://schemas.openxmlformats.org/drawingml/2006/main">
               <a:ext uri="{FF2B5EF4-FFF2-40B4-BE49-F238E27FC236}">
-                <a16:creationId xmlns:a16="http://schemas.microsoft.com/office/drawing/2014/main" id="{74CAA6ED-ADFE-4A62-8F4E-E98C042B7B44}"/>
+                <a16:creationId xmlns:a16="http://schemas.microsoft.com/office/drawing/2014/main" id="{28F4CD09-0119-47CD-862E-9315D736F114}"/>
               </a:ext>
             </a:extLst>
           </p:cNvPr>
@@ -4277,7 +4371,7 @@
           <p:cNvPr id="4" name="">
             <a:extLst xmlns:a="http://schemas.openxmlformats.org/drawingml/2006/main">
               <a:ext uri="{FF2B5EF4-FFF2-40B4-BE49-F238E27FC236}">
-                <a16:creationId xmlns:a16="http://schemas.microsoft.com/office/drawing/2014/main" id="{5DBD67E7-9294-434C-BFD9-2205F06E8C64}"/>
+                <a16:creationId xmlns:a16="http://schemas.microsoft.com/office/drawing/2014/main" id="{698C26B9-34B6-403C-9DC3-C5F86A9663AE}"/>
               </a:ext>
             </a:extLst>
           </p:cNvPr>
@@ -4334,7 +4428,7 @@
           <p:cNvPr id="5" name="">
             <a:extLst xmlns:a="http://schemas.openxmlformats.org/drawingml/2006/main">
               <a:ext uri="{FF2B5EF4-FFF2-40B4-BE49-F238E27FC236}">
-                <a16:creationId xmlns:a16="http://schemas.microsoft.com/office/drawing/2014/main" id="{2AB77A1F-D42E-4F26-AAED-5A311A7030C9}"/>
+                <a16:creationId xmlns:a16="http://schemas.microsoft.com/office/drawing/2014/main" id="{5407F11D-9EB0-4509-BB06-F7452D671760}"/>
               </a:ext>
             </a:extLst>
           </p:cNvPr>
@@ -4364,7 +4458,7 @@
           <p:cNvPr id="6" name="">
             <a:extLst xmlns:a="http://schemas.openxmlformats.org/drawingml/2006/main">
               <a:ext uri="{FF2B5EF4-FFF2-40B4-BE49-F238E27FC236}">
-                <a16:creationId xmlns:a16="http://schemas.microsoft.com/office/drawing/2014/main" id="{5E8AEC9F-436C-4C72-9459-9EC7E6924371}"/>
+                <a16:creationId xmlns:a16="http://schemas.microsoft.com/office/drawing/2014/main" id="{5DAB237D-70BC-4DAF-9370-79F6E02EB891}"/>
               </a:ext>
             </a:extLst>
           </p:cNvPr>
@@ -4421,7 +4515,7 @@
           <p:cNvPr id="7" name="">
             <a:extLst xmlns:a="http://schemas.openxmlformats.org/drawingml/2006/main">
               <a:ext uri="{FF2B5EF4-FFF2-40B4-BE49-F238E27FC236}">
-                <a16:creationId xmlns:a16="http://schemas.microsoft.com/office/drawing/2014/main" id="{453A8F36-982B-4378-8148-62243FDC2D71}"/>
+                <a16:creationId xmlns:a16="http://schemas.microsoft.com/office/drawing/2014/main" id="{686BA20B-46EC-476B-9CDD-2B738004377B}"/>
               </a:ext>
             </a:extLst>
           </p:cNvPr>
@@ -4478,7 +4572,7 @@
           <p:cNvPr id="8" name="">
             <a:extLst xmlns:a="http://schemas.openxmlformats.org/drawingml/2006/main">
               <a:ext uri="{FF2B5EF4-FFF2-40B4-BE49-F238E27FC236}">
-                <a16:creationId xmlns:a16="http://schemas.microsoft.com/office/drawing/2014/main" id="{A524D56A-1D22-4735-A64A-E88729BE6820}"/>
+                <a16:creationId xmlns:a16="http://schemas.microsoft.com/office/drawing/2014/main" id="{F9268A0F-05A0-473D-9F6E-0379F5E48B7F}"/>
               </a:ext>
             </a:extLst>
           </p:cNvPr>
@@ -4535,7 +4629,7 @@
           <p:cNvPr id="9" name="">
             <a:extLst xmlns:a="http://schemas.openxmlformats.org/drawingml/2006/main">
               <a:ext uri="{FF2B5EF4-FFF2-40B4-BE49-F238E27FC236}">
-                <a16:creationId xmlns:a16="http://schemas.microsoft.com/office/drawing/2014/main" id="{0FF614EA-4E0C-4341-A2E4-B38E73E5FBA1}"/>
+                <a16:creationId xmlns:a16="http://schemas.microsoft.com/office/drawing/2014/main" id="{38541EB3-A06F-4F32-9042-7F60729BC872}"/>
               </a:ext>
             </a:extLst>
           </p:cNvPr>
@@ -4569,7 +4663,7 @@
           <p:cNvPr id="10" name="">
             <a:extLst xmlns:a="http://schemas.openxmlformats.org/drawingml/2006/main">
               <a:ext uri="{FF2B5EF4-FFF2-40B4-BE49-F238E27FC236}">
-                <a16:creationId xmlns:a16="http://schemas.microsoft.com/office/drawing/2014/main" id="{BA649B2B-3583-45A3-899E-39E3CA85E3D3}"/>
+                <a16:creationId xmlns:a16="http://schemas.microsoft.com/office/drawing/2014/main" id="{C459D07D-64F6-4E6A-9608-F2AB65FE9CB6}"/>
               </a:ext>
             </a:extLst>
           </p:cNvPr>
@@ -4601,7 +4695,7 @@
           <p:cNvPr id="11" name="">
             <a:extLst xmlns:a="http://schemas.openxmlformats.org/drawingml/2006/main">
               <a:ext uri="{FF2B5EF4-FFF2-40B4-BE49-F238E27FC236}">
-                <a16:creationId xmlns:a16="http://schemas.microsoft.com/office/drawing/2014/main" id="{8F5E62D3-4C19-4C59-A972-EBBDD5D8FE5E}"/>
+                <a16:creationId xmlns:a16="http://schemas.microsoft.com/office/drawing/2014/main" id="{50855746-3066-4BE2-A333-7ADD0B341669}"/>
               </a:ext>
             </a:extLst>
           </p:cNvPr>
@@ -4658,7 +4752,7 @@
           <p:cNvPr id="12" name="">
             <a:extLst xmlns:a="http://schemas.openxmlformats.org/drawingml/2006/main">
               <a:ext uri="{FF2B5EF4-FFF2-40B4-BE49-F238E27FC236}">
-                <a16:creationId xmlns:a16="http://schemas.microsoft.com/office/drawing/2014/main" id="{EB97F008-5015-4EA2-B62B-C1B8CA96EDAB}"/>
+                <a16:creationId xmlns:a16="http://schemas.microsoft.com/office/drawing/2014/main" id="{C5B94EBE-34F1-48CC-B141-42137CF16F4E}"/>
               </a:ext>
             </a:extLst>
           </p:cNvPr>
@@ -4715,7 +4809,7 @@
           <p:cNvPr id="13" name="">
             <a:extLst xmlns:a="http://schemas.openxmlformats.org/drawingml/2006/main">
               <a:ext uri="{FF2B5EF4-FFF2-40B4-BE49-F238E27FC236}">
-                <a16:creationId xmlns:a16="http://schemas.microsoft.com/office/drawing/2014/main" id="{0CAB9521-91BC-429B-A277-0DD32BFCB31A}"/>
+                <a16:creationId xmlns:a16="http://schemas.microsoft.com/office/drawing/2014/main" id="{D9374CF6-531C-4B46-9030-2E819A766AF8}"/>
               </a:ext>
             </a:extLst>
           </p:cNvPr>
@@ -4772,7 +4866,7 @@
           <p:cNvPr id="14" name="">
             <a:extLst xmlns:a="http://schemas.openxmlformats.org/drawingml/2006/main">
               <a:ext uri="{FF2B5EF4-FFF2-40B4-BE49-F238E27FC236}">
-                <a16:creationId xmlns:a16="http://schemas.microsoft.com/office/drawing/2014/main" id="{998BF69E-37C0-4F6B-9834-B2C358575E36}"/>
+                <a16:creationId xmlns:a16="http://schemas.microsoft.com/office/drawing/2014/main" id="{7BDBF467-AD20-496D-A5C0-0540F6D45756}"/>
               </a:ext>
             </a:extLst>
           </p:cNvPr>
@@ -4829,7 +4923,7 @@
           <p:cNvPr id="15" name="">
             <a:extLst xmlns:a="http://schemas.openxmlformats.org/drawingml/2006/main">
               <a:ext uri="{FF2B5EF4-FFF2-40B4-BE49-F238E27FC236}">
-                <a16:creationId xmlns:a16="http://schemas.microsoft.com/office/drawing/2014/main" id="{364A2B51-4F9A-4F67-998F-18A99C312A56}"/>
+                <a16:creationId xmlns:a16="http://schemas.microsoft.com/office/drawing/2014/main" id="{97BE4943-C984-4713-9033-6A7157C230E9}"/>
               </a:ext>
             </a:extLst>
           </p:cNvPr>
@@ -4863,7 +4957,7 @@
           <p:cNvPr id="16" name="">
             <a:extLst xmlns:a="http://schemas.openxmlformats.org/drawingml/2006/main">
               <a:ext uri="{FF2B5EF4-FFF2-40B4-BE49-F238E27FC236}">
-                <a16:creationId xmlns:a16="http://schemas.microsoft.com/office/drawing/2014/main" id="{A88FB732-F2A4-4504-B88E-D30FF9272547}"/>
+                <a16:creationId xmlns:a16="http://schemas.microsoft.com/office/drawing/2014/main" id="{E1C8BF3E-D528-45D2-8159-1EC2A99B41A7}"/>
               </a:ext>
             </a:extLst>
           </p:cNvPr>
@@ -4895,7 +4989,7 @@
           <p:cNvPr id="17" name="">
             <a:extLst xmlns:a="http://schemas.openxmlformats.org/drawingml/2006/main">
               <a:ext uri="{FF2B5EF4-FFF2-40B4-BE49-F238E27FC236}">
-                <a16:creationId xmlns:a16="http://schemas.microsoft.com/office/drawing/2014/main" id="{50806F02-D2EB-40CD-8DF8-9C1081855716}"/>
+                <a16:creationId xmlns:a16="http://schemas.microsoft.com/office/drawing/2014/main" id="{E2711466-54B3-4F4C-8791-9F209BAAEEF2}"/>
               </a:ext>
             </a:extLst>
           </p:cNvPr>
@@ -4952,7 +5046,7 @@
           <p:cNvPr id="18" name="">
             <a:extLst xmlns:a="http://schemas.openxmlformats.org/drawingml/2006/main">
               <a:ext uri="{FF2B5EF4-FFF2-40B4-BE49-F238E27FC236}">
-                <a16:creationId xmlns:a16="http://schemas.microsoft.com/office/drawing/2014/main" id="{6DD81CDB-3D0B-493E-B06F-5275F51B56CB}"/>
+                <a16:creationId xmlns:a16="http://schemas.microsoft.com/office/drawing/2014/main" id="{8BDF4DCF-A2C4-4AE5-8701-AD60D8AC52FE}"/>
               </a:ext>
             </a:extLst>
           </p:cNvPr>
@@ -5009,7 +5103,7 @@
           <p:cNvPr id="19" name="">
             <a:extLst xmlns:a="http://schemas.openxmlformats.org/drawingml/2006/main">
               <a:ext uri="{FF2B5EF4-FFF2-40B4-BE49-F238E27FC236}">
-                <a16:creationId xmlns:a16="http://schemas.microsoft.com/office/drawing/2014/main" id="{1F092124-9B42-4618-B959-2B0C3BE88B46}"/>
+                <a16:creationId xmlns:a16="http://schemas.microsoft.com/office/drawing/2014/main" id="{4FB02946-053A-47BA-92FC-125C297E8F36}"/>
               </a:ext>
             </a:extLst>
           </p:cNvPr>
@@ -5066,7 +5160,7 @@
           <p:cNvPr id="20" name="">
             <a:extLst xmlns:a="http://schemas.openxmlformats.org/drawingml/2006/main">
               <a:ext uri="{FF2B5EF4-FFF2-40B4-BE49-F238E27FC236}">
-                <a16:creationId xmlns:a16="http://schemas.microsoft.com/office/drawing/2014/main" id="{E056ED27-7ADE-4ABA-9D27-DA93CCD41DD5}"/>
+                <a16:creationId xmlns:a16="http://schemas.microsoft.com/office/drawing/2014/main" id="{1C6E07DC-7553-4CD7-ABEB-D4DAC0EC4140}"/>
               </a:ext>
             </a:extLst>
           </p:cNvPr>
@@ -5123,7 +5217,7 @@
           <p:cNvPr id="21" name="">
             <a:extLst xmlns:a="http://schemas.openxmlformats.org/drawingml/2006/main">
               <a:ext uri="{FF2B5EF4-FFF2-40B4-BE49-F238E27FC236}">
-                <a16:creationId xmlns:a16="http://schemas.microsoft.com/office/drawing/2014/main" id="{FE041D4F-851B-4D8F-B5C5-BAF0127C3174}"/>
+                <a16:creationId xmlns:a16="http://schemas.microsoft.com/office/drawing/2014/main" id="{CDEB628A-D8F6-45CC-B063-B9BA6FAEBB63}"/>
               </a:ext>
             </a:extLst>
           </p:cNvPr>
@@ -5157,7 +5251,7 @@
           <p:cNvPr id="22" name="">
             <a:extLst xmlns:a="http://schemas.openxmlformats.org/drawingml/2006/main">
               <a:ext uri="{FF2B5EF4-FFF2-40B4-BE49-F238E27FC236}">
-                <a16:creationId xmlns:a16="http://schemas.microsoft.com/office/drawing/2014/main" id="{BB572AAA-01C3-4FC4-94F6-CEF25BAB9AA0}"/>
+                <a16:creationId xmlns:a16="http://schemas.microsoft.com/office/drawing/2014/main" id="{4A98CCFD-DED1-4EAC-8AB8-D78B5971DC91}"/>
               </a:ext>
             </a:extLst>
           </p:cNvPr>
@@ -5189,7 +5283,7 @@
           <p:cNvPr id="23" name="">
             <a:extLst xmlns:a="http://schemas.openxmlformats.org/drawingml/2006/main">
               <a:ext uri="{FF2B5EF4-FFF2-40B4-BE49-F238E27FC236}">
-                <a16:creationId xmlns:a16="http://schemas.microsoft.com/office/drawing/2014/main" id="{EAB64032-0348-4F7D-9EEF-049AD632E2EA}"/>
+                <a16:creationId xmlns:a16="http://schemas.microsoft.com/office/drawing/2014/main" id="{43DC15A9-A0E6-4C99-8160-128AE7F89B6F}"/>
               </a:ext>
             </a:extLst>
           </p:cNvPr>
@@ -5246,7 +5340,7 @@
           <p:cNvPr id="24" name="">
             <a:extLst xmlns:a="http://schemas.openxmlformats.org/drawingml/2006/main">
               <a:ext uri="{FF2B5EF4-FFF2-40B4-BE49-F238E27FC236}">
-                <a16:creationId xmlns:a16="http://schemas.microsoft.com/office/drawing/2014/main" id="{25CBFE01-6A5E-4D30-B08A-9F45ABC17223}"/>
+                <a16:creationId xmlns:a16="http://schemas.microsoft.com/office/drawing/2014/main" id="{8D0A8993-2A78-4AC0-9E7F-6463509A757A}"/>
               </a:ext>
             </a:extLst>
           </p:cNvPr>
@@ -5303,7 +5397,7 @@
           <p:cNvPr id="25" name="">
             <a:extLst xmlns:a="http://schemas.openxmlformats.org/drawingml/2006/main">
               <a:ext uri="{FF2B5EF4-FFF2-40B4-BE49-F238E27FC236}">
-                <a16:creationId xmlns:a16="http://schemas.microsoft.com/office/drawing/2014/main" id="{B890A068-AC9D-4CB4-A217-43A13EA64E7B}"/>
+                <a16:creationId xmlns:a16="http://schemas.microsoft.com/office/drawing/2014/main" id="{D944CC56-D8EB-47A5-8810-AE73014FD34C}"/>
               </a:ext>
             </a:extLst>
           </p:cNvPr>
@@ -5360,7 +5454,7 @@
           <p:cNvPr id="26" name="">
             <a:extLst xmlns:a="http://schemas.openxmlformats.org/drawingml/2006/main">
               <a:ext uri="{FF2B5EF4-FFF2-40B4-BE49-F238E27FC236}">
-                <a16:creationId xmlns:a16="http://schemas.microsoft.com/office/drawing/2014/main" id="{8F290C64-484C-4ECA-BDF2-CC636C0D9ECF}"/>
+                <a16:creationId xmlns:a16="http://schemas.microsoft.com/office/drawing/2014/main" id="{788B880A-4A4F-4C15-9123-F60287AEAF29}"/>
               </a:ext>
             </a:extLst>
           </p:cNvPr>
@@ -5417,7 +5511,7 @@
           <p:cNvPr id="27" name="">
             <a:extLst xmlns:a="http://schemas.openxmlformats.org/drawingml/2006/main">
               <a:ext uri="{FF2B5EF4-FFF2-40B4-BE49-F238E27FC236}">
-                <a16:creationId xmlns:a16="http://schemas.microsoft.com/office/drawing/2014/main" id="{A0B015E0-D8BF-401A-97DA-FE8F327F65CA}"/>
+                <a16:creationId xmlns:a16="http://schemas.microsoft.com/office/drawing/2014/main" id="{B9E5DBF1-A298-4C88-88B6-FEC0DD88881B}"/>
               </a:ext>
             </a:extLst>
           </p:cNvPr>
@@ -5451,7 +5545,7 @@
           <p:cNvPr id="28" name="">
             <a:extLst xmlns:a="http://schemas.openxmlformats.org/drawingml/2006/main">
               <a:ext uri="{FF2B5EF4-FFF2-40B4-BE49-F238E27FC236}">
-                <a16:creationId xmlns:a16="http://schemas.microsoft.com/office/drawing/2014/main" id="{E2069ABC-88AC-4BA8-B232-A7C93DD3FAAF}"/>
+                <a16:creationId xmlns:a16="http://schemas.microsoft.com/office/drawing/2014/main" id="{7DE5718E-776E-46EC-9628-4E5FAD466E26}"/>
               </a:ext>
             </a:extLst>
           </p:cNvPr>
@@ -5483,7 +5577,7 @@
           <p:cNvPr id="29" name="">
             <a:extLst xmlns:a="http://schemas.openxmlformats.org/drawingml/2006/main">
               <a:ext uri="{FF2B5EF4-FFF2-40B4-BE49-F238E27FC236}">
-                <a16:creationId xmlns:a16="http://schemas.microsoft.com/office/drawing/2014/main" id="{1FB5F14C-6E8A-4A09-9A5A-EDDCAB3F0593}"/>
+                <a16:creationId xmlns:a16="http://schemas.microsoft.com/office/drawing/2014/main" id="{C4BED743-0A2E-4A65-956A-95F112111D6B}"/>
               </a:ext>
             </a:extLst>
           </p:cNvPr>
@@ -5540,7 +5634,7 @@
           <p:cNvPr id="30" name="">
             <a:extLst xmlns:a="http://schemas.openxmlformats.org/drawingml/2006/main">
               <a:ext uri="{FF2B5EF4-FFF2-40B4-BE49-F238E27FC236}">
-                <a16:creationId xmlns:a16="http://schemas.microsoft.com/office/drawing/2014/main" id="{7FB98F4F-0AFD-4807-8C3C-7C72934F346C}"/>
+                <a16:creationId xmlns:a16="http://schemas.microsoft.com/office/drawing/2014/main" id="{B53F697B-DC66-4ECA-9635-E5049D9E0525}"/>
               </a:ext>
             </a:extLst>
           </p:cNvPr>
@@ -5597,7 +5691,7 @@
           <p:cNvPr id="31" name="">
             <a:extLst xmlns:a="http://schemas.openxmlformats.org/drawingml/2006/main">
               <a:ext uri="{FF2B5EF4-FFF2-40B4-BE49-F238E27FC236}">
-                <a16:creationId xmlns:a16="http://schemas.microsoft.com/office/drawing/2014/main" id="{8770C18C-F2C5-406B-92E1-3D1F95272A2D}"/>
+                <a16:creationId xmlns:a16="http://schemas.microsoft.com/office/drawing/2014/main" id="{7F574D05-7A82-43BD-9A8D-D4D0F9DC34EB}"/>
               </a:ext>
             </a:extLst>
           </p:cNvPr>
@@ -5654,7 +5748,7 @@
           <p:cNvPr id="32" name="">
             <a:extLst xmlns:a="http://schemas.openxmlformats.org/drawingml/2006/main">
               <a:ext uri="{FF2B5EF4-FFF2-40B4-BE49-F238E27FC236}">
-                <a16:creationId xmlns:a16="http://schemas.microsoft.com/office/drawing/2014/main" id="{03D898A3-0546-451B-951C-BBF5B90944F1}"/>
+                <a16:creationId xmlns:a16="http://schemas.microsoft.com/office/drawing/2014/main" id="{0AC25391-23C4-4687-8D1F-26E2ADCD8D9A}"/>
               </a:ext>
             </a:extLst>
           </p:cNvPr>
@@ -5688,7 +5782,7 @@
           <p:cNvPr id="33" name="">
             <a:extLst xmlns:a="http://schemas.openxmlformats.org/drawingml/2006/main">
               <a:ext uri="{FF2B5EF4-FFF2-40B4-BE49-F238E27FC236}">
-                <a16:creationId xmlns:a16="http://schemas.microsoft.com/office/drawing/2014/main" id="{EECD6785-5C69-4AA3-83F1-F1A0EABF5E90}"/>
+                <a16:creationId xmlns:a16="http://schemas.microsoft.com/office/drawing/2014/main" id="{3993C3E4-6F07-43A5-98EC-6D8FE77D190A}"/>
               </a:ext>
             </a:extLst>
           </p:cNvPr>
@@ -5745,7 +5839,7 @@
           <p:cNvPr id="34" name="">
             <a:extLst xmlns:a="http://schemas.openxmlformats.org/drawingml/2006/main">
               <a:ext uri="{FF2B5EF4-FFF2-40B4-BE49-F238E27FC236}">
-                <a16:creationId xmlns:a16="http://schemas.microsoft.com/office/drawing/2014/main" id="{08805ACF-E711-481F-984C-95EB41D82010}"/>
+                <a16:creationId xmlns:a16="http://schemas.microsoft.com/office/drawing/2014/main" id="{76C98F90-4F3C-400F-BA48-80D2054EDC3E}"/>
               </a:ext>
             </a:extLst>
           </p:cNvPr>
@@ -5802,7 +5896,7 @@
           <p:cNvPr id="35" name="">
             <a:extLst xmlns:a="http://schemas.openxmlformats.org/drawingml/2006/main">
               <a:ext uri="{FF2B5EF4-FFF2-40B4-BE49-F238E27FC236}">
-                <a16:creationId xmlns:a16="http://schemas.microsoft.com/office/drawing/2014/main" id="{C52A6E79-41A7-48D4-BCE2-6EA7996F3D9C}"/>
+                <a16:creationId xmlns:a16="http://schemas.microsoft.com/office/drawing/2014/main" id="{3AA87FC3-BDF3-4088-B6C9-298C51FDC76B}"/>
               </a:ext>
             </a:extLst>
           </p:cNvPr>
@@ -5859,7 +5953,7 @@
           <p:cNvPr id="36" name="">
             <a:extLst xmlns:a="http://schemas.openxmlformats.org/drawingml/2006/main">
               <a:ext uri="{FF2B5EF4-FFF2-40B4-BE49-F238E27FC236}">
-                <a16:creationId xmlns:a16="http://schemas.microsoft.com/office/drawing/2014/main" id="{F3771228-A443-497A-9C5E-CC19E6ECC79E}"/>
+                <a16:creationId xmlns:a16="http://schemas.microsoft.com/office/drawing/2014/main" id="{2BC9525D-393F-4265-A139-6E598281D65D}"/>
               </a:ext>
             </a:extLst>
           </p:cNvPr>
@@ -5893,7 +5987,7 @@
           <p:cNvPr id="37" name="">
             <a:extLst xmlns:a="http://schemas.openxmlformats.org/drawingml/2006/main">
               <a:ext uri="{FF2B5EF4-FFF2-40B4-BE49-F238E27FC236}">
-                <a16:creationId xmlns:a16="http://schemas.microsoft.com/office/drawing/2014/main" id="{D222321D-511F-4884-8DC8-24D326587DF9}"/>
+                <a16:creationId xmlns:a16="http://schemas.microsoft.com/office/drawing/2014/main" id="{27620C6C-2F55-4CFD-9A93-FAFC0B68C28F}"/>
               </a:ext>
             </a:extLst>
           </p:cNvPr>
@@ -5950,7 +6044,7 @@
           <p:cNvPr id="38" name="">
             <a:extLst xmlns:a="http://schemas.openxmlformats.org/drawingml/2006/main">
               <a:ext uri="{FF2B5EF4-FFF2-40B4-BE49-F238E27FC236}">
-                <a16:creationId xmlns:a16="http://schemas.microsoft.com/office/drawing/2014/main" id="{2832F31C-21B9-419B-837D-C76B8CBD49E8}"/>
+                <a16:creationId xmlns:a16="http://schemas.microsoft.com/office/drawing/2014/main" id="{4CD00992-FD87-47BA-89EF-4A117EBCAB2B}"/>
               </a:ext>
             </a:extLst>
           </p:cNvPr>
@@ -6007,7 +6101,7 @@
           <p:cNvPr id="39" name="">
             <a:extLst xmlns:a="http://schemas.openxmlformats.org/drawingml/2006/main">
               <a:ext uri="{FF2B5EF4-FFF2-40B4-BE49-F238E27FC236}">
-                <a16:creationId xmlns:a16="http://schemas.microsoft.com/office/drawing/2014/main" id="{E8FC97A2-5E60-4D6A-9327-E73E319722BF}"/>
+                <a16:creationId xmlns:a16="http://schemas.microsoft.com/office/drawing/2014/main" id="{A326FD0B-DD7B-4BAF-BD9D-4E18653C7068}"/>
               </a:ext>
             </a:extLst>
           </p:cNvPr>
@@ -6062,7 +6156,7 @@
     </p:spTree>
     <p:extLst>
       <p:ext uri="{BB962C8B-B14F-4D97-AF65-F5344CB8AC3E}">
-        <p14:creationId xmlns:p14="http://schemas.microsoft.com/office/powerpoint/2010/main" val="182237472"/>
+        <p14:creationId xmlns:p14="http://schemas.microsoft.com/office/powerpoint/2010/main" val="1471253571"/>
       </p:ext>
     </p:extLst>
   </p:cSld>
@@ -6093,7 +6187,7 @@
           <p:cNvPr id="38" name="">
             <a:extLst xmlns:a="http://schemas.openxmlformats.org/drawingml/2006/main">
               <a:ext uri="{FF2B5EF4-FFF2-40B4-BE49-F238E27FC236}">
-                <a16:creationId xmlns:a16="http://schemas.microsoft.com/office/drawing/2014/main" id="{45C64484-62AC-4D4E-BDB0-DB077852F8DE}"/>
+                <a16:creationId xmlns:a16="http://schemas.microsoft.com/office/drawing/2014/main" id="{EAE80D96-433E-4620-8E5F-4DFED14B1A7B}"/>
               </a:ext>
             </a:extLst>
           </p:cNvPr>
@@ -6150,7 +6244,7 @@
           <p:cNvPr id="2" name="">
             <a:extLst xmlns:a="http://schemas.openxmlformats.org/drawingml/2006/main">
               <a:ext uri="{FF2B5EF4-FFF2-40B4-BE49-F238E27FC236}">
-                <a16:creationId xmlns:a16="http://schemas.microsoft.com/office/drawing/2014/main" id="{8E431DEA-5C5A-4E66-A7A3-71F6628C77B3}"/>
+                <a16:creationId xmlns:a16="http://schemas.microsoft.com/office/drawing/2014/main" id="{EE555744-225B-4EA3-838C-93A7D1C4F66C}"/>
               </a:ext>
             </a:extLst>
           </p:cNvPr>
@@ -6180,7 +6274,7 @@
           <p:cNvPr id="3" name="">
             <a:extLst xmlns:a="http://schemas.openxmlformats.org/drawingml/2006/main">
               <a:ext uri="{FF2B5EF4-FFF2-40B4-BE49-F238E27FC236}">
-                <a16:creationId xmlns:a16="http://schemas.microsoft.com/office/drawing/2014/main" id="{A1C4BFFD-9631-4D32-8740-2EFC1B0A27B7}"/>
+                <a16:creationId xmlns:a16="http://schemas.microsoft.com/office/drawing/2014/main" id="{DED919A1-A852-41CD-905F-74D891A6C2A8}"/>
               </a:ext>
             </a:extLst>
           </p:cNvPr>
@@ -6237,7 +6331,7 @@
           <p:cNvPr id="4" name="">
             <a:extLst xmlns:a="http://schemas.openxmlformats.org/drawingml/2006/main">
               <a:ext uri="{FF2B5EF4-FFF2-40B4-BE49-F238E27FC236}">
-                <a16:creationId xmlns:a16="http://schemas.microsoft.com/office/drawing/2014/main" id="{56D083BC-514C-4DFE-8AC8-8A31AE3FC2C0}"/>
+                <a16:creationId xmlns:a16="http://schemas.microsoft.com/office/drawing/2014/main" id="{730EE787-3DBF-4F8C-B5A9-EBE9C2483FE4}"/>
               </a:ext>
             </a:extLst>
           </p:cNvPr>
@@ -6294,7 +6388,7 @@
           <p:cNvPr id="5" name="">
             <a:extLst xmlns:a="http://schemas.openxmlformats.org/drawingml/2006/main">
               <a:ext uri="{FF2B5EF4-FFF2-40B4-BE49-F238E27FC236}">
-                <a16:creationId xmlns:a16="http://schemas.microsoft.com/office/drawing/2014/main" id="{19A8A566-2484-4267-A01D-E0A628CAE3C4}"/>
+                <a16:creationId xmlns:a16="http://schemas.microsoft.com/office/drawing/2014/main" id="{C79EAAEF-ED9D-4F46-A8FD-B4ED2A02B227}"/>
               </a:ext>
             </a:extLst>
           </p:cNvPr>
@@ -6324,7 +6418,7 @@
           <p:cNvPr id="6" name="">
             <a:extLst xmlns:a="http://schemas.openxmlformats.org/drawingml/2006/main">
               <a:ext uri="{FF2B5EF4-FFF2-40B4-BE49-F238E27FC236}">
-                <a16:creationId xmlns:a16="http://schemas.microsoft.com/office/drawing/2014/main" id="{B429B0D5-3669-4CF2-981F-E7510BEF1E1C}"/>
+                <a16:creationId xmlns:a16="http://schemas.microsoft.com/office/drawing/2014/main" id="{FCAB5DEF-BAF6-4AD9-A6F9-A71A0ADCC100}"/>
               </a:ext>
             </a:extLst>
           </p:cNvPr>
@@ -6381,7 +6475,7 @@
           <p:cNvPr id="7" name="">
             <a:extLst xmlns:a="http://schemas.openxmlformats.org/drawingml/2006/main">
               <a:ext uri="{FF2B5EF4-FFF2-40B4-BE49-F238E27FC236}">
-                <a16:creationId xmlns:a16="http://schemas.microsoft.com/office/drawing/2014/main" id="{1F57234F-30CE-4EBD-A77B-B61450BAD692}"/>
+                <a16:creationId xmlns:a16="http://schemas.microsoft.com/office/drawing/2014/main" id="{37A2D00F-0213-4144-8AFD-B9EB87A372A9}"/>
               </a:ext>
             </a:extLst>
           </p:cNvPr>
@@ -6438,7 +6532,7 @@
           <p:cNvPr id="8" name="">
             <a:extLst xmlns:a="http://schemas.openxmlformats.org/drawingml/2006/main">
               <a:ext uri="{FF2B5EF4-FFF2-40B4-BE49-F238E27FC236}">
-                <a16:creationId xmlns:a16="http://schemas.microsoft.com/office/drawing/2014/main" id="{B249E810-9429-4E4A-ADF7-E849242CA3F6}"/>
+                <a16:creationId xmlns:a16="http://schemas.microsoft.com/office/drawing/2014/main" id="{62C79B98-95DC-4A3C-B827-FB247A047908}"/>
               </a:ext>
             </a:extLst>
           </p:cNvPr>
@@ -6495,7 +6589,7 @@
           <p:cNvPr id="9" name="">
             <a:extLst xmlns:a="http://schemas.openxmlformats.org/drawingml/2006/main">
               <a:ext uri="{FF2B5EF4-FFF2-40B4-BE49-F238E27FC236}">
-                <a16:creationId xmlns:a16="http://schemas.microsoft.com/office/drawing/2014/main" id="{EF90BFA5-0CB1-4C74-A30C-567410C4FFB4}"/>
+                <a16:creationId xmlns:a16="http://schemas.microsoft.com/office/drawing/2014/main" id="{C5EB7571-1810-44DD-BCBF-3847398E4169}"/>
               </a:ext>
             </a:extLst>
           </p:cNvPr>
@@ -6529,7 +6623,7 @@
           <p:cNvPr id="10" name="">
             <a:extLst xmlns:a="http://schemas.openxmlformats.org/drawingml/2006/main">
               <a:ext uri="{FF2B5EF4-FFF2-40B4-BE49-F238E27FC236}">
-                <a16:creationId xmlns:a16="http://schemas.microsoft.com/office/drawing/2014/main" id="{DFD3FE12-F992-483E-B9B9-7C24A0FB94C2}"/>
+                <a16:creationId xmlns:a16="http://schemas.microsoft.com/office/drawing/2014/main" id="{096B90ED-C51A-4A61-A911-EF6F651758C3}"/>
               </a:ext>
             </a:extLst>
           </p:cNvPr>
@@ -6586,7 +6680,7 @@
           <p:cNvPr id="11" name="">
             <a:extLst xmlns:a="http://schemas.openxmlformats.org/drawingml/2006/main">
               <a:ext uri="{FF2B5EF4-FFF2-40B4-BE49-F238E27FC236}">
-                <a16:creationId xmlns:a16="http://schemas.microsoft.com/office/drawing/2014/main" id="{ECC7AD94-CA49-4AE6-B4DE-E07301F9AC4C}"/>
+                <a16:creationId xmlns:a16="http://schemas.microsoft.com/office/drawing/2014/main" id="{FF4C3170-FBBE-4A4D-B4E3-3DCE0A0FC239}"/>
               </a:ext>
             </a:extLst>
           </p:cNvPr>
@@ -6643,7 +6737,7 @@
           <p:cNvPr id="12" name="">
             <a:extLst xmlns:a="http://schemas.openxmlformats.org/drawingml/2006/main">
               <a:ext uri="{FF2B5EF4-FFF2-40B4-BE49-F238E27FC236}">
-                <a16:creationId xmlns:a16="http://schemas.microsoft.com/office/drawing/2014/main" id="{11FB3196-1619-4628-8B6F-8FE33B61572E}"/>
+                <a16:creationId xmlns:a16="http://schemas.microsoft.com/office/drawing/2014/main" id="{D02E6041-E915-471E-9E5F-FDBFD445F8BB}"/>
               </a:ext>
             </a:extLst>
           </p:cNvPr>
@@ -6677,7 +6771,7 @@
           <p:cNvPr id="13" name="">
             <a:extLst xmlns:a="http://schemas.openxmlformats.org/drawingml/2006/main">
               <a:ext uri="{FF2B5EF4-FFF2-40B4-BE49-F238E27FC236}">
-                <a16:creationId xmlns:a16="http://schemas.microsoft.com/office/drawing/2014/main" id="{098EA9DE-0DE9-4041-8462-B1E90E30A943}"/>
+                <a16:creationId xmlns:a16="http://schemas.microsoft.com/office/drawing/2014/main" id="{5F783221-87D5-48D5-8134-F5D67BC34CC6}"/>
               </a:ext>
             </a:extLst>
           </p:cNvPr>
@@ -6734,7 +6828,7 @@
           <p:cNvPr id="14" name="">
             <a:extLst xmlns:a="http://schemas.openxmlformats.org/drawingml/2006/main">
               <a:ext uri="{FF2B5EF4-FFF2-40B4-BE49-F238E27FC236}">
-                <a16:creationId xmlns:a16="http://schemas.microsoft.com/office/drawing/2014/main" id="{F9EA9DE1-95E8-4E0A-8AA4-BCE4A747BE4A}"/>
+                <a16:creationId xmlns:a16="http://schemas.microsoft.com/office/drawing/2014/main" id="{5DB20DDC-AEAD-430B-B2B5-B315AECDCF58}"/>
               </a:ext>
             </a:extLst>
           </p:cNvPr>
@@ -6791,7 +6885,7 @@
           <p:cNvPr id="15" name="">
             <a:extLst xmlns:a="http://schemas.openxmlformats.org/drawingml/2006/main">
               <a:ext uri="{FF2B5EF4-FFF2-40B4-BE49-F238E27FC236}">
-                <a16:creationId xmlns:a16="http://schemas.microsoft.com/office/drawing/2014/main" id="{C65BAA3F-6C2A-4D15-AA86-A860BFBA1704}"/>
+                <a16:creationId xmlns:a16="http://schemas.microsoft.com/office/drawing/2014/main" id="{074EA3FA-1B36-4C0D-BBDD-65E9E006F314}"/>
               </a:ext>
             </a:extLst>
           </p:cNvPr>
@@ -6821,7 +6915,7 @@
           <p:cNvPr id="16" name="">
             <a:extLst xmlns:a="http://schemas.openxmlformats.org/drawingml/2006/main">
               <a:ext uri="{FF2B5EF4-FFF2-40B4-BE49-F238E27FC236}">
-                <a16:creationId xmlns:a16="http://schemas.microsoft.com/office/drawing/2014/main" id="{B878CA9C-4981-4439-8787-7816327DAFCD}"/>
+                <a16:creationId xmlns:a16="http://schemas.microsoft.com/office/drawing/2014/main" id="{1440AB85-93DF-4D88-BBD8-D5348F9E0EB3}"/>
               </a:ext>
             </a:extLst>
           </p:cNvPr>
@@ -6851,7 +6945,7 @@
           <p:cNvPr id="17" name="">
             <a:extLst xmlns:a="http://schemas.openxmlformats.org/drawingml/2006/main">
               <a:ext uri="{FF2B5EF4-FFF2-40B4-BE49-F238E27FC236}">
-                <a16:creationId xmlns:a16="http://schemas.microsoft.com/office/drawing/2014/main" id="{C6065AC7-6817-4DE2-9BAC-A045FA3739DC}"/>
+                <a16:creationId xmlns:a16="http://schemas.microsoft.com/office/drawing/2014/main" id="{BB1CCBCA-D75C-42C4-B500-040DDDAE6D56}"/>
               </a:ext>
             </a:extLst>
           </p:cNvPr>
@@ -6881,7 +6975,7 @@
           <p:cNvPr id="18" name="">
             <a:extLst xmlns:a="http://schemas.openxmlformats.org/drawingml/2006/main">
               <a:ext uri="{FF2B5EF4-FFF2-40B4-BE49-F238E27FC236}">
-                <a16:creationId xmlns:a16="http://schemas.microsoft.com/office/drawing/2014/main" id="{E2DBC327-C832-42AB-B431-2CF97F3C2218}"/>
+                <a16:creationId xmlns:a16="http://schemas.microsoft.com/office/drawing/2014/main" id="{6FB0D55D-38B8-463D-A4D6-37301CEE0B05}"/>
               </a:ext>
             </a:extLst>
           </p:cNvPr>
@@ -6915,7 +7009,7 @@
           <p:cNvPr id="19" name="">
             <a:extLst xmlns:a="http://schemas.openxmlformats.org/drawingml/2006/main">
               <a:ext uri="{FF2B5EF4-FFF2-40B4-BE49-F238E27FC236}">
-                <a16:creationId xmlns:a16="http://schemas.microsoft.com/office/drawing/2014/main" id="{9888C37F-60A1-4106-9ECA-04B3AA260C4A}"/>
+                <a16:creationId xmlns:a16="http://schemas.microsoft.com/office/drawing/2014/main" id="{D336D970-BA06-4E6A-A0ED-29144D6DE30E}"/>
               </a:ext>
             </a:extLst>
           </p:cNvPr>
@@ -6972,7 +7066,7 @@
           <p:cNvPr id="20" name="">
             <a:extLst xmlns:a="http://schemas.openxmlformats.org/drawingml/2006/main">
               <a:ext uri="{FF2B5EF4-FFF2-40B4-BE49-F238E27FC236}">
-                <a16:creationId xmlns:a16="http://schemas.microsoft.com/office/drawing/2014/main" id="{83BB72AC-FCA6-4A37-8C08-5EC059609959}"/>
+                <a16:creationId xmlns:a16="http://schemas.microsoft.com/office/drawing/2014/main" id="{0A7C3E1F-7A0B-4F90-A32B-DB1125C8599B}"/>
               </a:ext>
             </a:extLst>
           </p:cNvPr>
@@ -7052,7 +7146,7 @@
           <p:cNvPr id="21" name="">
             <a:extLst xmlns:a="http://schemas.openxmlformats.org/drawingml/2006/main">
               <a:ext uri="{FF2B5EF4-FFF2-40B4-BE49-F238E27FC236}">
-                <a16:creationId xmlns:a16="http://schemas.microsoft.com/office/drawing/2014/main" id="{1D694CC1-EAE6-4AA8-8489-D2CD6CEAE7D6}"/>
+                <a16:creationId xmlns:a16="http://schemas.microsoft.com/office/drawing/2014/main" id="{7B065D06-1C65-4DDB-BCB1-94BA2328DEFF}"/>
               </a:ext>
             </a:extLst>
           </p:cNvPr>
@@ -7082,7 +7176,7 @@
           <p:cNvPr id="22" name="">
             <a:extLst xmlns:a="http://schemas.openxmlformats.org/drawingml/2006/main">
               <a:ext uri="{FF2B5EF4-FFF2-40B4-BE49-F238E27FC236}">
-                <a16:creationId xmlns:a16="http://schemas.microsoft.com/office/drawing/2014/main" id="{21DBB375-9CC4-4B18-8FAF-27E3AFDBA5B4}"/>
+                <a16:creationId xmlns:a16="http://schemas.microsoft.com/office/drawing/2014/main" id="{D3B8EB90-9AF7-43BB-B9CA-D75A8126F421}"/>
               </a:ext>
             </a:extLst>
           </p:cNvPr>
@@ -7116,7 +7210,7 @@
           <p:cNvPr id="23" name="">
             <a:extLst xmlns:a="http://schemas.openxmlformats.org/drawingml/2006/main">
               <a:ext uri="{FF2B5EF4-FFF2-40B4-BE49-F238E27FC236}">
-                <a16:creationId xmlns:a16="http://schemas.microsoft.com/office/drawing/2014/main" id="{F788EC68-25BE-4E07-B2A3-89B0D9AF1999}"/>
+                <a16:creationId xmlns:a16="http://schemas.microsoft.com/office/drawing/2014/main" id="{60C9503F-5EF5-4F5E-A7BF-2635C3365F37}"/>
               </a:ext>
             </a:extLst>
           </p:cNvPr>
@@ -7173,7 +7267,7 @@
           <p:cNvPr id="24" name="">
             <a:extLst xmlns:a="http://schemas.openxmlformats.org/drawingml/2006/main">
               <a:ext uri="{FF2B5EF4-FFF2-40B4-BE49-F238E27FC236}">
-                <a16:creationId xmlns:a16="http://schemas.microsoft.com/office/drawing/2014/main" id="{68E2F268-83F9-4D4F-A3D0-5AB4C8DF876E}"/>
+                <a16:creationId xmlns:a16="http://schemas.microsoft.com/office/drawing/2014/main" id="{ACE30CED-920A-4AFA-9DFB-86B7DCFC4D0B}"/>
               </a:ext>
             </a:extLst>
           </p:cNvPr>
@@ -7253,7 +7347,7 @@
           <p:cNvPr id="25" name="">
             <a:extLst xmlns:a="http://schemas.openxmlformats.org/drawingml/2006/main">
               <a:ext uri="{FF2B5EF4-FFF2-40B4-BE49-F238E27FC236}">
-                <a16:creationId xmlns:a16="http://schemas.microsoft.com/office/drawing/2014/main" id="{29CAAF6C-AF71-494C-A6B6-30FC23F120C9}"/>
+                <a16:creationId xmlns:a16="http://schemas.microsoft.com/office/drawing/2014/main" id="{60A2A384-C32A-45A8-AD77-569DF32C2A1A}"/>
               </a:ext>
             </a:extLst>
           </p:cNvPr>
@@ -7283,7 +7377,7 @@
           <p:cNvPr id="26" name="">
             <a:extLst xmlns:a="http://schemas.openxmlformats.org/drawingml/2006/main">
               <a:ext uri="{FF2B5EF4-FFF2-40B4-BE49-F238E27FC236}">
-                <a16:creationId xmlns:a16="http://schemas.microsoft.com/office/drawing/2014/main" id="{DC1AC3FF-914A-46B3-973B-EECA79B001F8}"/>
+                <a16:creationId xmlns:a16="http://schemas.microsoft.com/office/drawing/2014/main" id="{A2A711DB-64AF-46A0-AE02-69B9004D599B}"/>
               </a:ext>
             </a:extLst>
           </p:cNvPr>
@@ -7317,7 +7411,7 @@
           <p:cNvPr id="27" name="">
             <a:extLst xmlns:a="http://schemas.openxmlformats.org/drawingml/2006/main">
               <a:ext uri="{FF2B5EF4-FFF2-40B4-BE49-F238E27FC236}">
-                <a16:creationId xmlns:a16="http://schemas.microsoft.com/office/drawing/2014/main" id="{604292D0-FAF9-4B11-9E7F-6E4E0319868A}"/>
+                <a16:creationId xmlns:a16="http://schemas.microsoft.com/office/drawing/2014/main" id="{FDD2F939-8C14-4284-A394-64A58DE6046E}"/>
               </a:ext>
             </a:extLst>
           </p:cNvPr>
@@ -7374,7 +7468,7 @@
           <p:cNvPr id="28" name="">
             <a:extLst xmlns:a="http://schemas.openxmlformats.org/drawingml/2006/main">
               <a:ext uri="{FF2B5EF4-FFF2-40B4-BE49-F238E27FC236}">
-                <a16:creationId xmlns:a16="http://schemas.microsoft.com/office/drawing/2014/main" id="{4DB7701F-99EE-446E-8BEB-88F0B7B94E4A}"/>
+                <a16:creationId xmlns:a16="http://schemas.microsoft.com/office/drawing/2014/main" id="{3855224D-A771-45A2-B05A-1FAFC5A63DA7}"/>
               </a:ext>
             </a:extLst>
           </p:cNvPr>
@@ -7454,7 +7548,7 @@
           <p:cNvPr id="29" name="">
             <a:extLst xmlns:a="http://schemas.openxmlformats.org/drawingml/2006/main">
               <a:ext uri="{FF2B5EF4-FFF2-40B4-BE49-F238E27FC236}">
-                <a16:creationId xmlns:a16="http://schemas.microsoft.com/office/drawing/2014/main" id="{CFA9E56C-1E60-47F1-A6A9-B217C150FB75}"/>
+                <a16:creationId xmlns:a16="http://schemas.microsoft.com/office/drawing/2014/main" id="{43D64E01-2D08-4DFE-953C-DFF6D7040E41}"/>
               </a:ext>
             </a:extLst>
           </p:cNvPr>
@@ -7484,7 +7578,7 @@
           <p:cNvPr id="30" name="">
             <a:extLst xmlns:a="http://schemas.openxmlformats.org/drawingml/2006/main">
               <a:ext uri="{FF2B5EF4-FFF2-40B4-BE49-F238E27FC236}">
-                <a16:creationId xmlns:a16="http://schemas.microsoft.com/office/drawing/2014/main" id="{10B32449-99C3-4A1A-A484-E0D776A27C42}"/>
+                <a16:creationId xmlns:a16="http://schemas.microsoft.com/office/drawing/2014/main" id="{6CA97AA3-0783-4157-8FD5-1E90BBE5E025}"/>
               </a:ext>
             </a:extLst>
           </p:cNvPr>
@@ -7514,7 +7608,7 @@
           <p:cNvPr id="31" name="">
             <a:extLst xmlns:a="http://schemas.openxmlformats.org/drawingml/2006/main">
               <a:ext uri="{FF2B5EF4-FFF2-40B4-BE49-F238E27FC236}">
-                <a16:creationId xmlns:a16="http://schemas.microsoft.com/office/drawing/2014/main" id="{82FA99D9-3787-4070-A45B-29E0349E8E5B}"/>
+                <a16:creationId xmlns:a16="http://schemas.microsoft.com/office/drawing/2014/main" id="{DEF1009C-EEA7-420D-8B59-51F7F2806A59}"/>
               </a:ext>
             </a:extLst>
           </p:cNvPr>
@@ -7544,7 +7638,7 @@
           <p:cNvPr id="32" name="">
             <a:extLst xmlns:a="http://schemas.openxmlformats.org/drawingml/2006/main">
               <a:ext uri="{FF2B5EF4-FFF2-40B4-BE49-F238E27FC236}">
-                <a16:creationId xmlns:a16="http://schemas.microsoft.com/office/drawing/2014/main" id="{D9811341-EC8C-4458-8D1A-9CDA1B5D0900}"/>
+                <a16:creationId xmlns:a16="http://schemas.microsoft.com/office/drawing/2014/main" id="{B7AE2849-5C49-4DBD-8AE1-901453289E84}"/>
               </a:ext>
             </a:extLst>
           </p:cNvPr>
@@ -7574,7 +7668,7 @@
           <p:cNvPr id="33" name="">
             <a:extLst xmlns:a="http://schemas.openxmlformats.org/drawingml/2006/main">
               <a:ext uri="{FF2B5EF4-FFF2-40B4-BE49-F238E27FC236}">
-                <a16:creationId xmlns:a16="http://schemas.microsoft.com/office/drawing/2014/main" id="{EA60F75B-7AF3-41D4-A649-EF425227995B}"/>
+                <a16:creationId xmlns:a16="http://schemas.microsoft.com/office/drawing/2014/main" id="{2B7F5389-A3BA-4997-A0AD-34AF9549E06A}"/>
               </a:ext>
             </a:extLst>
           </p:cNvPr>
@@ -7631,7 +7725,7 @@
           <p:cNvPr id="34" name="">
             <a:extLst xmlns:a="http://schemas.openxmlformats.org/drawingml/2006/main">
               <a:ext uri="{FF2B5EF4-FFF2-40B4-BE49-F238E27FC236}">
-                <a16:creationId xmlns:a16="http://schemas.microsoft.com/office/drawing/2014/main" id="{4B028707-4DA0-4636-93CC-5873C7F4CCD6}"/>
+                <a16:creationId xmlns:a16="http://schemas.microsoft.com/office/drawing/2014/main" id="{150D8332-C31B-4B05-83E7-09BACDFA8D0E}"/>
               </a:ext>
             </a:extLst>
           </p:cNvPr>
@@ -7665,7 +7759,7 @@
           <p:cNvPr id="35" name="">
             <a:extLst xmlns:a="http://schemas.openxmlformats.org/drawingml/2006/main">
               <a:ext uri="{FF2B5EF4-FFF2-40B4-BE49-F238E27FC236}">
-                <a16:creationId xmlns:a16="http://schemas.microsoft.com/office/drawing/2014/main" id="{572856B3-5E4B-42B9-A9C3-BF3E06ED5BCE}"/>
+                <a16:creationId xmlns:a16="http://schemas.microsoft.com/office/drawing/2014/main" id="{F1307A97-69F0-463F-A74E-E86523CDC7C1}"/>
               </a:ext>
             </a:extLst>
           </p:cNvPr>
@@ -7722,7 +7816,7 @@
           <p:cNvPr id="36" name="">
             <a:extLst xmlns:a="http://schemas.openxmlformats.org/drawingml/2006/main">
               <a:ext uri="{FF2B5EF4-FFF2-40B4-BE49-F238E27FC236}">
-                <a16:creationId xmlns:a16="http://schemas.microsoft.com/office/drawing/2014/main" id="{563A4631-2657-44A6-BE6F-5A5DE3E65DED}"/>
+                <a16:creationId xmlns:a16="http://schemas.microsoft.com/office/drawing/2014/main" id="{4758FD62-33E6-43B5-A7A5-C82777FB98FD}"/>
               </a:ext>
             </a:extLst>
           </p:cNvPr>
@@ -7756,7 +7850,7 @@
           <p:cNvPr id="37" name="">
             <a:extLst xmlns:a="http://schemas.openxmlformats.org/drawingml/2006/main">
               <a:ext uri="{FF2B5EF4-FFF2-40B4-BE49-F238E27FC236}">
-                <a16:creationId xmlns:a16="http://schemas.microsoft.com/office/drawing/2014/main" id="{1F0B12B8-11BF-4FCF-A111-BFF1C6396E25}"/>
+                <a16:creationId xmlns:a16="http://schemas.microsoft.com/office/drawing/2014/main" id="{BCDA9661-74A5-4907-8D3B-FEF5C6237490}"/>
               </a:ext>
             </a:extLst>
           </p:cNvPr>
@@ -7811,7 +7905,7 @@
     </p:spTree>
     <p:extLst>
       <p:ext uri="{BB962C8B-B14F-4D97-AF65-F5344CB8AC3E}">
-        <p14:creationId xmlns:p14="http://schemas.microsoft.com/office/powerpoint/2010/main" val="1657427693"/>
+        <p14:creationId xmlns:p14="http://schemas.microsoft.com/office/powerpoint/2010/main" val="920664915"/>
       </p:ext>
     </p:extLst>
   </p:cSld>
@@ -7842,7 +7936,7 @@
           <p:cNvPr id="40" name="">
             <a:extLst xmlns:a="http://schemas.openxmlformats.org/drawingml/2006/main">
               <a:ext uri="{FF2B5EF4-FFF2-40B4-BE49-F238E27FC236}">
-                <a16:creationId xmlns:a16="http://schemas.microsoft.com/office/drawing/2014/main" id="{00F70A9E-0605-41B0-98BF-035D34EEFC17}"/>
+                <a16:creationId xmlns:a16="http://schemas.microsoft.com/office/drawing/2014/main" id="{852163B3-70BF-429F-B546-13104632BC45}"/>
               </a:ext>
             </a:extLst>
           </p:cNvPr>
@@ -7899,7 +7993,7 @@
           <p:cNvPr id="2" name="">
             <a:extLst xmlns:a="http://schemas.openxmlformats.org/drawingml/2006/main">
               <a:ext uri="{FF2B5EF4-FFF2-40B4-BE49-F238E27FC236}">
-                <a16:creationId xmlns:a16="http://schemas.microsoft.com/office/drawing/2014/main" id="{4B5363B4-DCE9-4671-B787-24986092958C}"/>
+                <a16:creationId xmlns:a16="http://schemas.microsoft.com/office/drawing/2014/main" id="{7CEB9C8F-EB29-4B57-90B3-14925946E2F5}"/>
               </a:ext>
             </a:extLst>
           </p:cNvPr>
@@ -7929,7 +8023,7 @@
           <p:cNvPr id="3" name="">
             <a:extLst xmlns:a="http://schemas.openxmlformats.org/drawingml/2006/main">
               <a:ext uri="{FF2B5EF4-FFF2-40B4-BE49-F238E27FC236}">
-                <a16:creationId xmlns:a16="http://schemas.microsoft.com/office/drawing/2014/main" id="{72AC6FC8-DABD-404B-8B93-DC556E35E5CF}"/>
+                <a16:creationId xmlns:a16="http://schemas.microsoft.com/office/drawing/2014/main" id="{37727C41-6DE2-42A6-B29A-C4A664D0EBA0}"/>
               </a:ext>
             </a:extLst>
           </p:cNvPr>
@@ -7986,7 +8080,7 @@
           <p:cNvPr id="4" name="">
             <a:extLst xmlns:a="http://schemas.openxmlformats.org/drawingml/2006/main">
               <a:ext uri="{FF2B5EF4-FFF2-40B4-BE49-F238E27FC236}">
-                <a16:creationId xmlns:a16="http://schemas.microsoft.com/office/drawing/2014/main" id="{1D554A36-65D0-4D2F-A1C8-A486E9DDA4B3}"/>
+                <a16:creationId xmlns:a16="http://schemas.microsoft.com/office/drawing/2014/main" id="{EEDE9F04-CAD4-4D67-A918-3B847ACFCD6F}"/>
               </a:ext>
             </a:extLst>
           </p:cNvPr>
@@ -8043,7 +8137,7 @@
           <p:cNvPr id="5" name="">
             <a:extLst xmlns:a="http://schemas.openxmlformats.org/drawingml/2006/main">
               <a:ext uri="{FF2B5EF4-FFF2-40B4-BE49-F238E27FC236}">
-                <a16:creationId xmlns:a16="http://schemas.microsoft.com/office/drawing/2014/main" id="{A143AAA4-8C71-4F01-9A4E-E8E35C924633}"/>
+                <a16:creationId xmlns:a16="http://schemas.microsoft.com/office/drawing/2014/main" id="{F02AC456-FE30-46DB-8B4D-E8621101435E}"/>
               </a:ext>
             </a:extLst>
           </p:cNvPr>
@@ -8073,7 +8167,7 @@
           <p:cNvPr id="6" name="">
             <a:extLst xmlns:a="http://schemas.openxmlformats.org/drawingml/2006/main">
               <a:ext uri="{FF2B5EF4-FFF2-40B4-BE49-F238E27FC236}">
-                <a16:creationId xmlns:a16="http://schemas.microsoft.com/office/drawing/2014/main" id="{09BC08E4-A748-4036-B8A0-1627A157CFF0}"/>
+                <a16:creationId xmlns:a16="http://schemas.microsoft.com/office/drawing/2014/main" id="{48625328-D0E2-4BC0-8D16-D2F9F4ED3E1C}"/>
               </a:ext>
             </a:extLst>
           </p:cNvPr>
@@ -8130,7 +8224,7 @@
           <p:cNvPr id="7" name="">
             <a:extLst xmlns:a="http://schemas.openxmlformats.org/drawingml/2006/main">
               <a:ext uri="{FF2B5EF4-FFF2-40B4-BE49-F238E27FC236}">
-                <a16:creationId xmlns:a16="http://schemas.microsoft.com/office/drawing/2014/main" id="{C46B5FF1-70FF-450B-B328-7D86608D3C97}"/>
+                <a16:creationId xmlns:a16="http://schemas.microsoft.com/office/drawing/2014/main" id="{A3A180BD-C1F4-406E-BEA6-411C7BC0CBB2}"/>
               </a:ext>
             </a:extLst>
           </p:cNvPr>
@@ -8187,7 +8281,7 @@
           <p:cNvPr id="8" name="">
             <a:extLst xmlns:a="http://schemas.openxmlformats.org/drawingml/2006/main">
               <a:ext uri="{FF2B5EF4-FFF2-40B4-BE49-F238E27FC236}">
-                <a16:creationId xmlns:a16="http://schemas.microsoft.com/office/drawing/2014/main" id="{9217E7DE-DB6B-46A7-80E3-A0FCCA636FCB}"/>
+                <a16:creationId xmlns:a16="http://schemas.microsoft.com/office/drawing/2014/main" id="{046F8D52-1334-49A3-B8E6-1421CAC0CD78}"/>
               </a:ext>
             </a:extLst>
           </p:cNvPr>
@@ -8244,7 +8338,7 @@
           <p:cNvPr id="9" name="">
             <a:extLst xmlns:a="http://schemas.openxmlformats.org/drawingml/2006/main">
               <a:ext uri="{FF2B5EF4-FFF2-40B4-BE49-F238E27FC236}">
-                <a16:creationId xmlns:a16="http://schemas.microsoft.com/office/drawing/2014/main" id="{859CFC84-BF2D-4ABC-88D0-3098F46B95B9}"/>
+                <a16:creationId xmlns:a16="http://schemas.microsoft.com/office/drawing/2014/main" id="{384BB817-EE15-408A-9D51-60215574F992}"/>
               </a:ext>
             </a:extLst>
           </p:cNvPr>
@@ -8278,7 +8372,7 @@
           <p:cNvPr id="10" name="">
             <a:extLst xmlns:a="http://schemas.openxmlformats.org/drawingml/2006/main">
               <a:ext uri="{FF2B5EF4-FFF2-40B4-BE49-F238E27FC236}">
-                <a16:creationId xmlns:a16="http://schemas.microsoft.com/office/drawing/2014/main" id="{037BEFE4-2FC5-4C4F-A73D-D1C70E5DD712}"/>
+                <a16:creationId xmlns:a16="http://schemas.microsoft.com/office/drawing/2014/main" id="{E01E7175-4334-42E6-ABF8-8ADF5C347673}"/>
               </a:ext>
             </a:extLst>
           </p:cNvPr>
@@ -8335,7 +8429,7 @@
           <p:cNvPr id="11" name="">
             <a:extLst xmlns:a="http://schemas.openxmlformats.org/drawingml/2006/main">
               <a:ext uri="{FF2B5EF4-FFF2-40B4-BE49-F238E27FC236}">
-                <a16:creationId xmlns:a16="http://schemas.microsoft.com/office/drawing/2014/main" id="{1D49D087-EECF-40A8-8916-B1988B89728D}"/>
+                <a16:creationId xmlns:a16="http://schemas.microsoft.com/office/drawing/2014/main" id="{779A0222-3A21-430C-A6D4-4DA64988B6CB}"/>
               </a:ext>
             </a:extLst>
           </p:cNvPr>
@@ -8392,7 +8486,7 @@
           <p:cNvPr id="12" name="">
             <a:extLst xmlns:a="http://schemas.openxmlformats.org/drawingml/2006/main">
               <a:ext uri="{FF2B5EF4-FFF2-40B4-BE49-F238E27FC236}">
-                <a16:creationId xmlns:a16="http://schemas.microsoft.com/office/drawing/2014/main" id="{7F872A53-7639-4D38-B9D3-A7721A11927D}"/>
+                <a16:creationId xmlns:a16="http://schemas.microsoft.com/office/drawing/2014/main" id="{5B3F7D53-8E30-44EA-A2B1-B734F13B3EA3}"/>
               </a:ext>
             </a:extLst>
           </p:cNvPr>
@@ -8426,7 +8520,7 @@
           <p:cNvPr id="13" name="">
             <a:extLst xmlns:a="http://schemas.openxmlformats.org/drawingml/2006/main">
               <a:ext uri="{FF2B5EF4-FFF2-40B4-BE49-F238E27FC236}">
-                <a16:creationId xmlns:a16="http://schemas.microsoft.com/office/drawing/2014/main" id="{3987B550-5AF7-48BC-B354-5B8D946A9134}"/>
+                <a16:creationId xmlns:a16="http://schemas.microsoft.com/office/drawing/2014/main" id="{001325EA-5A55-41BE-8538-ABB51F6F0CF5}"/>
               </a:ext>
             </a:extLst>
           </p:cNvPr>
@@ -8483,7 +8577,7 @@
           <p:cNvPr id="14" name="">
             <a:extLst xmlns:a="http://schemas.openxmlformats.org/drawingml/2006/main">
               <a:ext uri="{FF2B5EF4-FFF2-40B4-BE49-F238E27FC236}">
-                <a16:creationId xmlns:a16="http://schemas.microsoft.com/office/drawing/2014/main" id="{7C6C6838-0015-4C09-B70C-A8A24BF35108}"/>
+                <a16:creationId xmlns:a16="http://schemas.microsoft.com/office/drawing/2014/main" id="{B90D1888-5A88-4B5D-9042-77C867FFD6DC}"/>
               </a:ext>
             </a:extLst>
           </p:cNvPr>
@@ -8540,7 +8634,7 @@
           <p:cNvPr id="15" name="">
             <a:extLst xmlns:a="http://schemas.openxmlformats.org/drawingml/2006/main">
               <a:ext uri="{FF2B5EF4-FFF2-40B4-BE49-F238E27FC236}">
-                <a16:creationId xmlns:a16="http://schemas.microsoft.com/office/drawing/2014/main" id="{F52DB931-F7F1-461B-9A80-A8174C88706F}"/>
+                <a16:creationId xmlns:a16="http://schemas.microsoft.com/office/drawing/2014/main" id="{281B3C46-27EF-47FB-A379-5EDA55F3C7AB}"/>
               </a:ext>
             </a:extLst>
           </p:cNvPr>
@@ -8597,7 +8691,7 @@
           <p:cNvPr id="16" name="">
             <a:extLst xmlns:a="http://schemas.openxmlformats.org/drawingml/2006/main">
               <a:ext uri="{FF2B5EF4-FFF2-40B4-BE49-F238E27FC236}">
-                <a16:creationId xmlns:a16="http://schemas.microsoft.com/office/drawing/2014/main" id="{0B125B1D-C305-4F04-AAFC-6315FF1F741E}"/>
+                <a16:creationId xmlns:a16="http://schemas.microsoft.com/office/drawing/2014/main" id="{4455B7C9-40A0-49AF-8462-48CA79761DA4}"/>
               </a:ext>
             </a:extLst>
           </p:cNvPr>
@@ -8627,7 +8721,7 @@
           <p:cNvPr id="17" name="">
             <a:extLst xmlns:a="http://schemas.openxmlformats.org/drawingml/2006/main">
               <a:ext uri="{FF2B5EF4-FFF2-40B4-BE49-F238E27FC236}">
-                <a16:creationId xmlns:a16="http://schemas.microsoft.com/office/drawing/2014/main" id="{CE782791-D23E-4F7D-8C07-AF3C69A9A0BD}"/>
+                <a16:creationId xmlns:a16="http://schemas.microsoft.com/office/drawing/2014/main" id="{9FCC6AA3-0645-4DAF-BBAC-5FBABE32AD66}"/>
               </a:ext>
             </a:extLst>
           </p:cNvPr>
@@ -8659,7 +8753,7 @@
           <p:cNvPr id="18" name="">
             <a:extLst xmlns:a="http://schemas.openxmlformats.org/drawingml/2006/main">
               <a:ext uri="{FF2B5EF4-FFF2-40B4-BE49-F238E27FC236}">
-                <a16:creationId xmlns:a16="http://schemas.microsoft.com/office/drawing/2014/main" id="{41B71507-983A-401A-A19C-412462F33592}"/>
+                <a16:creationId xmlns:a16="http://schemas.microsoft.com/office/drawing/2014/main" id="{892A1E4C-034C-472E-9698-7A3EBA8C545B}"/>
               </a:ext>
             </a:extLst>
           </p:cNvPr>
@@ -8716,7 +8810,7 @@
           <p:cNvPr id="19" name="">
             <a:extLst xmlns:a="http://schemas.openxmlformats.org/drawingml/2006/main">
               <a:ext uri="{FF2B5EF4-FFF2-40B4-BE49-F238E27FC236}">
-                <a16:creationId xmlns:a16="http://schemas.microsoft.com/office/drawing/2014/main" id="{0EB7505E-B872-451C-ACBD-2B3FA399D55D}"/>
+                <a16:creationId xmlns:a16="http://schemas.microsoft.com/office/drawing/2014/main" id="{F2E14415-B8FD-4DCA-987E-72BD6643738A}"/>
               </a:ext>
             </a:extLst>
           </p:cNvPr>
@@ -8748,7 +8842,7 @@
           <p:cNvPr id="20" name="">
             <a:extLst xmlns:a="http://schemas.openxmlformats.org/drawingml/2006/main">
               <a:ext uri="{FF2B5EF4-FFF2-40B4-BE49-F238E27FC236}">
-                <a16:creationId xmlns:a16="http://schemas.microsoft.com/office/drawing/2014/main" id="{FC72DBB7-5657-4B9B-B149-B64E6F623FA0}"/>
+                <a16:creationId xmlns:a16="http://schemas.microsoft.com/office/drawing/2014/main" id="{CF1A5B76-4256-460B-B546-E296891E407D}"/>
               </a:ext>
             </a:extLst>
           </p:cNvPr>
@@ -8805,7 +8899,7 @@
           <p:cNvPr id="21" name="">
             <a:extLst xmlns:a="http://schemas.openxmlformats.org/drawingml/2006/main">
               <a:ext uri="{FF2B5EF4-FFF2-40B4-BE49-F238E27FC236}">
-                <a16:creationId xmlns:a16="http://schemas.microsoft.com/office/drawing/2014/main" id="{2854FAF9-14FF-4ECB-BF27-5BD59DE711DA}"/>
+                <a16:creationId xmlns:a16="http://schemas.microsoft.com/office/drawing/2014/main" id="{DEA6ACF5-AA77-4B79-B157-7097D84D6FDB}"/>
               </a:ext>
             </a:extLst>
           </p:cNvPr>
@@ -8837,7 +8931,7 @@
           <p:cNvPr id="22" name="">
             <a:extLst xmlns:a="http://schemas.openxmlformats.org/drawingml/2006/main">
               <a:ext uri="{FF2B5EF4-FFF2-40B4-BE49-F238E27FC236}">
-                <a16:creationId xmlns:a16="http://schemas.microsoft.com/office/drawing/2014/main" id="{A22483F5-CDBA-499F-A37F-23742BF22164}"/>
+                <a16:creationId xmlns:a16="http://schemas.microsoft.com/office/drawing/2014/main" id="{B6F8FD94-9F05-43C5-A840-678EE85066A8}"/>
               </a:ext>
             </a:extLst>
           </p:cNvPr>
@@ -8894,7 +8988,7 @@
           <p:cNvPr id="23" name="">
             <a:extLst xmlns:a="http://schemas.openxmlformats.org/drawingml/2006/main">
               <a:ext uri="{FF2B5EF4-FFF2-40B4-BE49-F238E27FC236}">
-                <a16:creationId xmlns:a16="http://schemas.microsoft.com/office/drawing/2014/main" id="{41F5965A-3F43-41D9-BCCE-689DDEA0076C}"/>
+                <a16:creationId xmlns:a16="http://schemas.microsoft.com/office/drawing/2014/main" id="{3B598485-2248-4567-982C-662F7072920B}"/>
               </a:ext>
             </a:extLst>
           </p:cNvPr>
@@ -8926,7 +9020,7 @@
           <p:cNvPr id="24" name="">
             <a:extLst xmlns:a="http://schemas.openxmlformats.org/drawingml/2006/main">
               <a:ext uri="{FF2B5EF4-FFF2-40B4-BE49-F238E27FC236}">
-                <a16:creationId xmlns:a16="http://schemas.microsoft.com/office/drawing/2014/main" id="{BE5C52D4-11E7-4468-AF1A-4112D423CA62}"/>
+                <a16:creationId xmlns:a16="http://schemas.microsoft.com/office/drawing/2014/main" id="{CB8047EC-D96E-4BDD-9083-6E24C247005C}"/>
               </a:ext>
             </a:extLst>
           </p:cNvPr>
@@ -8983,7 +9077,7 @@
           <p:cNvPr id="25" name="">
             <a:extLst xmlns:a="http://schemas.openxmlformats.org/drawingml/2006/main">
               <a:ext uri="{FF2B5EF4-FFF2-40B4-BE49-F238E27FC236}">
-                <a16:creationId xmlns:a16="http://schemas.microsoft.com/office/drawing/2014/main" id="{9265847C-7FE5-4AD9-BFD7-D83FAD810840}"/>
+                <a16:creationId xmlns:a16="http://schemas.microsoft.com/office/drawing/2014/main" id="{05138F4A-8034-41D8-BAD0-1259DFD3BF65}"/>
               </a:ext>
             </a:extLst>
           </p:cNvPr>
@@ -9015,7 +9109,7 @@
           <p:cNvPr id="26" name="">
             <a:extLst xmlns:a="http://schemas.openxmlformats.org/drawingml/2006/main">
               <a:ext uri="{FF2B5EF4-FFF2-40B4-BE49-F238E27FC236}">
-                <a16:creationId xmlns:a16="http://schemas.microsoft.com/office/drawing/2014/main" id="{A94609C7-4341-47F3-857E-ECFA0F57215C}"/>
+                <a16:creationId xmlns:a16="http://schemas.microsoft.com/office/drawing/2014/main" id="{42DF232E-83E0-48E9-8BA9-35B065024E73}"/>
               </a:ext>
             </a:extLst>
           </p:cNvPr>
@@ -9072,7 +9166,7 @@
           <p:cNvPr id="27" name="">
             <a:extLst xmlns:a="http://schemas.openxmlformats.org/drawingml/2006/main">
               <a:ext uri="{FF2B5EF4-FFF2-40B4-BE49-F238E27FC236}">
-                <a16:creationId xmlns:a16="http://schemas.microsoft.com/office/drawing/2014/main" id="{442327E3-5A93-4C0D-AA9A-EE79CCC1D8A7}"/>
+                <a16:creationId xmlns:a16="http://schemas.microsoft.com/office/drawing/2014/main" id="{7C41A42A-A755-4C53-9556-A636F902B4B5}"/>
               </a:ext>
             </a:extLst>
           </p:cNvPr>
@@ -9129,7 +9223,7 @@
           <p:cNvPr id="28" name="">
             <a:extLst xmlns:a="http://schemas.openxmlformats.org/drawingml/2006/main">
               <a:ext uri="{FF2B5EF4-FFF2-40B4-BE49-F238E27FC236}">
-                <a16:creationId xmlns:a16="http://schemas.microsoft.com/office/drawing/2014/main" id="{89E53004-E6AD-459C-B520-04C0DA186883}"/>
+                <a16:creationId xmlns:a16="http://schemas.microsoft.com/office/drawing/2014/main" id="{AE238A1E-3A90-4C78-9120-1B1544CF2551}"/>
               </a:ext>
             </a:extLst>
           </p:cNvPr>
@@ -9186,7 +9280,7 @@
           <p:cNvPr id="29" name="">
             <a:extLst xmlns:a="http://schemas.openxmlformats.org/drawingml/2006/main">
               <a:ext uri="{FF2B5EF4-FFF2-40B4-BE49-F238E27FC236}">
-                <a16:creationId xmlns:a16="http://schemas.microsoft.com/office/drawing/2014/main" id="{D790F242-B691-4192-A36F-674CE55FF3B4}"/>
+                <a16:creationId xmlns:a16="http://schemas.microsoft.com/office/drawing/2014/main" id="{A9E139E8-4BDD-4F37-87D5-E69712AAA4E7}"/>
               </a:ext>
             </a:extLst>
           </p:cNvPr>
@@ -9243,7 +9337,7 @@
           <p:cNvPr id="30" name="">
             <a:extLst xmlns:a="http://schemas.openxmlformats.org/drawingml/2006/main">
               <a:ext uri="{FF2B5EF4-FFF2-40B4-BE49-F238E27FC236}">
-                <a16:creationId xmlns:a16="http://schemas.microsoft.com/office/drawing/2014/main" id="{659FFC91-8822-44BF-B9DA-690EBFFB675A}"/>
+                <a16:creationId xmlns:a16="http://schemas.microsoft.com/office/drawing/2014/main" id="{B0AA973A-2E86-4849-B5CF-4A29F4582297}"/>
               </a:ext>
             </a:extLst>
           </p:cNvPr>
@@ -9300,7 +9394,7 @@
           <p:cNvPr id="31" name="">
             <a:extLst xmlns:a="http://schemas.openxmlformats.org/drawingml/2006/main">
               <a:ext uri="{FF2B5EF4-FFF2-40B4-BE49-F238E27FC236}">
-                <a16:creationId xmlns:a16="http://schemas.microsoft.com/office/drawing/2014/main" id="{8C989A92-DD12-4192-B8D2-91BA1DC63853}"/>
+                <a16:creationId xmlns:a16="http://schemas.microsoft.com/office/drawing/2014/main" id="{B31B7140-D165-4EB1-A0C0-510663671A9C}"/>
               </a:ext>
             </a:extLst>
           </p:cNvPr>
@@ -9357,7 +9451,7 @@
           <p:cNvPr id="32" name="">
             <a:extLst xmlns:a="http://schemas.openxmlformats.org/drawingml/2006/main">
               <a:ext uri="{FF2B5EF4-FFF2-40B4-BE49-F238E27FC236}">
-                <a16:creationId xmlns:a16="http://schemas.microsoft.com/office/drawing/2014/main" id="{679FE7F7-843E-4CF1-84EF-884679DED4BF}"/>
+                <a16:creationId xmlns:a16="http://schemas.microsoft.com/office/drawing/2014/main" id="{F48CA0B4-0E9F-4AB5-AE14-FFB047C38511}"/>
               </a:ext>
             </a:extLst>
           </p:cNvPr>
@@ -9414,7 +9508,7 @@
           <p:cNvPr id="33" name="">
             <a:extLst xmlns:a="http://schemas.openxmlformats.org/drawingml/2006/main">
               <a:ext uri="{FF2B5EF4-FFF2-40B4-BE49-F238E27FC236}">
-                <a16:creationId xmlns:a16="http://schemas.microsoft.com/office/drawing/2014/main" id="{8C3AEF60-536B-4DFC-934F-458E1B80D6F3}"/>
+                <a16:creationId xmlns:a16="http://schemas.microsoft.com/office/drawing/2014/main" id="{00D5CB72-2228-48C1-BBED-A656BEBC3108}"/>
               </a:ext>
             </a:extLst>
           </p:cNvPr>
@@ -9471,7 +9565,7 @@
           <p:cNvPr id="34" name="">
             <a:extLst xmlns:a="http://schemas.openxmlformats.org/drawingml/2006/main">
               <a:ext uri="{FF2B5EF4-FFF2-40B4-BE49-F238E27FC236}">
-                <a16:creationId xmlns:a16="http://schemas.microsoft.com/office/drawing/2014/main" id="{37B0BCDA-355A-454F-A216-97536DA6902A}"/>
+                <a16:creationId xmlns:a16="http://schemas.microsoft.com/office/drawing/2014/main" id="{6E6417C4-B9C5-4540-98C6-66DBC2752EF7}"/>
               </a:ext>
             </a:extLst>
           </p:cNvPr>
@@ -9528,7 +9622,7 @@
           <p:cNvPr id="35" name="">
             <a:extLst xmlns:a="http://schemas.openxmlformats.org/drawingml/2006/main">
               <a:ext uri="{FF2B5EF4-FFF2-40B4-BE49-F238E27FC236}">
-                <a16:creationId xmlns:a16="http://schemas.microsoft.com/office/drawing/2014/main" id="{A1592860-6469-497F-8826-2545AED2BC07}"/>
+                <a16:creationId xmlns:a16="http://schemas.microsoft.com/office/drawing/2014/main" id="{3B9E0E2F-F2A9-4192-8E90-352CE88B20CC}"/>
               </a:ext>
             </a:extLst>
           </p:cNvPr>
@@ -9585,7 +9679,7 @@
           <p:cNvPr id="36" name="">
             <a:extLst xmlns:a="http://schemas.openxmlformats.org/drawingml/2006/main">
               <a:ext uri="{FF2B5EF4-FFF2-40B4-BE49-F238E27FC236}">
-                <a16:creationId xmlns:a16="http://schemas.microsoft.com/office/drawing/2014/main" id="{9ACA762E-CA9A-4111-9F0C-19758BCD070E}"/>
+                <a16:creationId xmlns:a16="http://schemas.microsoft.com/office/drawing/2014/main" id="{C8B01B3F-4B29-4822-A170-EE797C1E74C9}"/>
               </a:ext>
             </a:extLst>
           </p:cNvPr>
@@ -9642,7 +9736,7 @@
           <p:cNvPr id="37" name="">
             <a:extLst xmlns:a="http://schemas.openxmlformats.org/drawingml/2006/main">
               <a:ext uri="{FF2B5EF4-FFF2-40B4-BE49-F238E27FC236}">
-                <a16:creationId xmlns:a16="http://schemas.microsoft.com/office/drawing/2014/main" id="{2147643A-382B-46A1-A272-60E90A32181D}"/>
+                <a16:creationId xmlns:a16="http://schemas.microsoft.com/office/drawing/2014/main" id="{C0F04039-F1AA-44A3-AD6B-571BBD43D2F3}"/>
               </a:ext>
             </a:extLst>
           </p:cNvPr>
@@ -9699,7 +9793,7 @@
           <p:cNvPr id="38" name="">
             <a:extLst xmlns:a="http://schemas.openxmlformats.org/drawingml/2006/main">
               <a:ext uri="{FF2B5EF4-FFF2-40B4-BE49-F238E27FC236}">
-                <a16:creationId xmlns:a16="http://schemas.microsoft.com/office/drawing/2014/main" id="{197B2B89-7ADE-4261-9EFA-C6C9DB9C3F78}"/>
+                <a16:creationId xmlns:a16="http://schemas.microsoft.com/office/drawing/2014/main" id="{9127899D-E7EB-40FB-81D6-86FC635EB748}"/>
               </a:ext>
             </a:extLst>
           </p:cNvPr>
@@ -9756,7 +9850,7 @@
           <p:cNvPr id="39" name="">
             <a:extLst xmlns:a="http://schemas.openxmlformats.org/drawingml/2006/main">
               <a:ext uri="{FF2B5EF4-FFF2-40B4-BE49-F238E27FC236}">
-                <a16:creationId xmlns:a16="http://schemas.microsoft.com/office/drawing/2014/main" id="{22D5F7AD-914D-405A-B8A2-36C9E93BEBA7}"/>
+                <a16:creationId xmlns:a16="http://schemas.microsoft.com/office/drawing/2014/main" id="{3E418A1E-5584-4BA2-ACE7-8A15BAC43393}"/>
               </a:ext>
             </a:extLst>
           </p:cNvPr>
@@ -9811,7 +9905,7 @@
     </p:spTree>
     <p:extLst>
       <p:ext uri="{BB962C8B-B14F-4D97-AF65-F5344CB8AC3E}">
-        <p14:creationId xmlns:p14="http://schemas.microsoft.com/office/powerpoint/2010/main" val="228350666"/>
+        <p14:creationId xmlns:p14="http://schemas.microsoft.com/office/powerpoint/2010/main" val="968630961"/>
       </p:ext>
     </p:extLst>
   </p:cSld>
@@ -9842,7 +9936,7 @@
           <p:cNvPr id="40" name="">
             <a:extLst xmlns:a="http://schemas.openxmlformats.org/drawingml/2006/main">
               <a:ext uri="{FF2B5EF4-FFF2-40B4-BE49-F238E27FC236}">
-                <a16:creationId xmlns:a16="http://schemas.microsoft.com/office/drawing/2014/main" id="{04B3F5A0-B012-4356-AB78-42676B28E7DE}"/>
+                <a16:creationId xmlns:a16="http://schemas.microsoft.com/office/drawing/2014/main" id="{2824E94F-0DC1-48E9-A22F-1F419F41DED2}"/>
               </a:ext>
             </a:extLst>
           </p:cNvPr>
@@ -9899,7 +9993,7 @@
           <p:cNvPr id="2" name="">
             <a:extLst xmlns:a="http://schemas.openxmlformats.org/drawingml/2006/main">
               <a:ext uri="{FF2B5EF4-FFF2-40B4-BE49-F238E27FC236}">
-                <a16:creationId xmlns:a16="http://schemas.microsoft.com/office/drawing/2014/main" id="{9438E060-C95B-41DF-96B4-D0B26973331C}"/>
+                <a16:creationId xmlns:a16="http://schemas.microsoft.com/office/drawing/2014/main" id="{0973BD5C-AFCC-4E21-8D80-3A2C289A55FE}"/>
               </a:ext>
             </a:extLst>
           </p:cNvPr>
@@ -9929,7 +10023,7 @@
           <p:cNvPr id="3" name="">
             <a:extLst xmlns:a="http://schemas.openxmlformats.org/drawingml/2006/main">
               <a:ext uri="{FF2B5EF4-FFF2-40B4-BE49-F238E27FC236}">
-                <a16:creationId xmlns:a16="http://schemas.microsoft.com/office/drawing/2014/main" id="{7736E686-4F14-4D30-B829-A79F604622F9}"/>
+                <a16:creationId xmlns:a16="http://schemas.microsoft.com/office/drawing/2014/main" id="{EAF65238-63F7-44E6-B23B-384D91A423FB}"/>
               </a:ext>
             </a:extLst>
           </p:cNvPr>
@@ -9986,7 +10080,7 @@
           <p:cNvPr id="4" name="">
             <a:extLst xmlns:a="http://schemas.openxmlformats.org/drawingml/2006/main">
               <a:ext uri="{FF2B5EF4-FFF2-40B4-BE49-F238E27FC236}">
-                <a16:creationId xmlns:a16="http://schemas.microsoft.com/office/drawing/2014/main" id="{C42EEC5C-8483-4661-9406-0F562FB5E06C}"/>
+                <a16:creationId xmlns:a16="http://schemas.microsoft.com/office/drawing/2014/main" id="{0EA9B6A7-9870-4AF7-A2F3-C1F15B273424}"/>
               </a:ext>
             </a:extLst>
           </p:cNvPr>
@@ -10043,7 +10137,7 @@
           <p:cNvPr id="5" name="">
             <a:extLst xmlns:a="http://schemas.openxmlformats.org/drawingml/2006/main">
               <a:ext uri="{FF2B5EF4-FFF2-40B4-BE49-F238E27FC236}">
-                <a16:creationId xmlns:a16="http://schemas.microsoft.com/office/drawing/2014/main" id="{B37DA145-656D-4BBA-881B-C7A370842F3F}"/>
+                <a16:creationId xmlns:a16="http://schemas.microsoft.com/office/drawing/2014/main" id="{BA0BB49A-D62C-4350-A010-6E12F8DE5CC0}"/>
               </a:ext>
             </a:extLst>
           </p:cNvPr>
@@ -10073,7 +10167,7 @@
           <p:cNvPr id="6" name="">
             <a:extLst xmlns:a="http://schemas.openxmlformats.org/drawingml/2006/main">
               <a:ext uri="{FF2B5EF4-FFF2-40B4-BE49-F238E27FC236}">
-                <a16:creationId xmlns:a16="http://schemas.microsoft.com/office/drawing/2014/main" id="{9BBFC9EF-47CA-4372-8C5E-E262FE4AB403}"/>
+                <a16:creationId xmlns:a16="http://schemas.microsoft.com/office/drawing/2014/main" id="{FBD00442-EDF0-4D7C-A01A-B8FF437F0EDC}"/>
               </a:ext>
             </a:extLst>
           </p:cNvPr>
@@ -10130,7 +10224,7 @@
           <p:cNvPr id="7" name="">
             <a:extLst xmlns:a="http://schemas.openxmlformats.org/drawingml/2006/main">
               <a:ext uri="{FF2B5EF4-FFF2-40B4-BE49-F238E27FC236}">
-                <a16:creationId xmlns:a16="http://schemas.microsoft.com/office/drawing/2014/main" id="{02B70CF7-3B16-4E06-B5C1-9DB968FEA23C}"/>
+                <a16:creationId xmlns:a16="http://schemas.microsoft.com/office/drawing/2014/main" id="{937A773D-7224-439F-977E-A84F8EFD5BA9}"/>
               </a:ext>
             </a:extLst>
           </p:cNvPr>
@@ -10187,7 +10281,7 @@
           <p:cNvPr id="8" name="">
             <a:extLst xmlns:a="http://schemas.openxmlformats.org/drawingml/2006/main">
               <a:ext uri="{FF2B5EF4-FFF2-40B4-BE49-F238E27FC236}">
-                <a16:creationId xmlns:a16="http://schemas.microsoft.com/office/drawing/2014/main" id="{5B4B3EB3-F8CD-45C9-93D9-FF90AFB72CF7}"/>
+                <a16:creationId xmlns:a16="http://schemas.microsoft.com/office/drawing/2014/main" id="{B602958B-360E-4E16-A141-84703C7D118A}"/>
               </a:ext>
             </a:extLst>
           </p:cNvPr>
@@ -10244,7 +10338,7 @@
           <p:cNvPr id="9" name="">
             <a:extLst xmlns:a="http://schemas.openxmlformats.org/drawingml/2006/main">
               <a:ext uri="{FF2B5EF4-FFF2-40B4-BE49-F238E27FC236}">
-                <a16:creationId xmlns:a16="http://schemas.microsoft.com/office/drawing/2014/main" id="{C20A2B9E-7AE7-41BF-AE18-4C344C9B259A}"/>
+                <a16:creationId xmlns:a16="http://schemas.microsoft.com/office/drawing/2014/main" id="{2B9E3A23-B6AB-48F5-A004-FB285CD55FC3}"/>
               </a:ext>
             </a:extLst>
           </p:cNvPr>
@@ -10278,7 +10372,7 @@
           <p:cNvPr id="10" name="">
             <a:extLst xmlns:a="http://schemas.openxmlformats.org/drawingml/2006/main">
               <a:ext uri="{FF2B5EF4-FFF2-40B4-BE49-F238E27FC236}">
-                <a16:creationId xmlns:a16="http://schemas.microsoft.com/office/drawing/2014/main" id="{CA9C45D4-5BB4-4C08-8737-B5EE59ED4A8A}"/>
+                <a16:creationId xmlns:a16="http://schemas.microsoft.com/office/drawing/2014/main" id="{F498CD8E-21D8-4789-B11D-02E075578406}"/>
               </a:ext>
             </a:extLst>
           </p:cNvPr>
@@ -10312,7 +10406,7 @@
           <p:cNvPr id="11" name="">
             <a:extLst xmlns:a="http://schemas.openxmlformats.org/drawingml/2006/main">
               <a:ext uri="{FF2B5EF4-FFF2-40B4-BE49-F238E27FC236}">
-                <a16:creationId xmlns:a16="http://schemas.microsoft.com/office/drawing/2014/main" id="{4220B5B7-F214-4443-93B4-F7D203DC1E2D}"/>
+                <a16:creationId xmlns:a16="http://schemas.microsoft.com/office/drawing/2014/main" id="{1DDAAB9A-D909-47FF-B4D5-13376AB7899B}"/>
               </a:ext>
             </a:extLst>
           </p:cNvPr>
@@ -10369,7 +10463,7 @@
           <p:cNvPr id="12" name="">
             <a:extLst xmlns:a="http://schemas.openxmlformats.org/drawingml/2006/main">
               <a:ext uri="{FF2B5EF4-FFF2-40B4-BE49-F238E27FC236}">
-                <a16:creationId xmlns:a16="http://schemas.microsoft.com/office/drawing/2014/main" id="{7B96B71E-0AAE-4542-8D00-DE1CFC8632BA}"/>
+                <a16:creationId xmlns:a16="http://schemas.microsoft.com/office/drawing/2014/main" id="{CF5F0959-3FAC-4E17-BD0C-C6F50EC5C530}"/>
               </a:ext>
             </a:extLst>
           </p:cNvPr>
@@ -10426,7 +10520,7 @@
           <p:cNvPr id="13" name="">
             <a:extLst xmlns:a="http://schemas.openxmlformats.org/drawingml/2006/main">
               <a:ext uri="{FF2B5EF4-FFF2-40B4-BE49-F238E27FC236}">
-                <a16:creationId xmlns:a16="http://schemas.microsoft.com/office/drawing/2014/main" id="{4C93DE6F-C43E-433D-ACA6-3D15E2609D74}"/>
+                <a16:creationId xmlns:a16="http://schemas.microsoft.com/office/drawing/2014/main" id="{1A70F8E1-C401-4C80-B877-2DCF336A54F1}"/>
               </a:ext>
             </a:extLst>
           </p:cNvPr>
@@ -10456,7 +10550,7 @@
           <p:cNvPr id="14" name="">
             <a:extLst xmlns:a="http://schemas.openxmlformats.org/drawingml/2006/main">
               <a:ext uri="{FF2B5EF4-FFF2-40B4-BE49-F238E27FC236}">
-                <a16:creationId xmlns:a16="http://schemas.microsoft.com/office/drawing/2014/main" id="{F780F8E4-4868-4D56-B29E-33122F183E26}"/>
+                <a16:creationId xmlns:a16="http://schemas.microsoft.com/office/drawing/2014/main" id="{BD5C11DA-B2B9-4ADE-9301-F279792761D0}"/>
               </a:ext>
             </a:extLst>
           </p:cNvPr>
@@ -10559,7 +10653,7 @@
           <p:cNvPr id="15" name="">
             <a:extLst xmlns:a="http://schemas.openxmlformats.org/drawingml/2006/main">
               <a:ext uri="{FF2B5EF4-FFF2-40B4-BE49-F238E27FC236}">
-                <a16:creationId xmlns:a16="http://schemas.microsoft.com/office/drawing/2014/main" id="{F9373CC4-184A-4C4C-89E3-7A0B081F4339}"/>
+                <a16:creationId xmlns:a16="http://schemas.microsoft.com/office/drawing/2014/main" id="{FBF08334-A591-4CF5-9493-A5E9E2AC263B}"/>
               </a:ext>
             </a:extLst>
           </p:cNvPr>
@@ -10593,7 +10687,7 @@
           <p:cNvPr id="16" name="">
             <a:extLst xmlns:a="http://schemas.openxmlformats.org/drawingml/2006/main">
               <a:ext uri="{FF2B5EF4-FFF2-40B4-BE49-F238E27FC236}">
-                <a16:creationId xmlns:a16="http://schemas.microsoft.com/office/drawing/2014/main" id="{56E235B3-7E70-43DA-86E0-69D875F20213}"/>
+                <a16:creationId xmlns:a16="http://schemas.microsoft.com/office/drawing/2014/main" id="{983241A6-4166-46E1-B78D-B97FE3D70E42}"/>
               </a:ext>
             </a:extLst>
           </p:cNvPr>
@@ -10627,7 +10721,7 @@
           <p:cNvPr id="17" name="">
             <a:extLst xmlns:a="http://schemas.openxmlformats.org/drawingml/2006/main">
               <a:ext uri="{FF2B5EF4-FFF2-40B4-BE49-F238E27FC236}">
-                <a16:creationId xmlns:a16="http://schemas.microsoft.com/office/drawing/2014/main" id="{D4585FFC-7901-4B1A-8A56-78DF8EF581DD}"/>
+                <a16:creationId xmlns:a16="http://schemas.microsoft.com/office/drawing/2014/main" id="{6FB7301A-2A5F-498A-B1A5-04A2686D53CA}"/>
               </a:ext>
             </a:extLst>
           </p:cNvPr>
@@ -10684,7 +10778,7 @@
           <p:cNvPr id="18" name="">
             <a:extLst xmlns:a="http://schemas.openxmlformats.org/drawingml/2006/main">
               <a:ext uri="{FF2B5EF4-FFF2-40B4-BE49-F238E27FC236}">
-                <a16:creationId xmlns:a16="http://schemas.microsoft.com/office/drawing/2014/main" id="{99DA1B65-E828-4E5D-9652-5396EABB874B}"/>
+                <a16:creationId xmlns:a16="http://schemas.microsoft.com/office/drawing/2014/main" id="{D29143BE-8A64-45C1-AF5D-407C7BF0D9FF}"/>
               </a:ext>
             </a:extLst>
           </p:cNvPr>
@@ -10741,7 +10835,7 @@
           <p:cNvPr id="19" name="">
             <a:extLst xmlns:a="http://schemas.openxmlformats.org/drawingml/2006/main">
               <a:ext uri="{FF2B5EF4-FFF2-40B4-BE49-F238E27FC236}">
-                <a16:creationId xmlns:a16="http://schemas.microsoft.com/office/drawing/2014/main" id="{2BA01042-683B-4081-A6DD-2BD17D3884D7}"/>
+                <a16:creationId xmlns:a16="http://schemas.microsoft.com/office/drawing/2014/main" id="{20A56AFD-6D4B-4C82-B7FC-981D221430EE}"/>
               </a:ext>
             </a:extLst>
           </p:cNvPr>
@@ -10771,7 +10865,7 @@
           <p:cNvPr id="20" name="">
             <a:extLst xmlns:a="http://schemas.openxmlformats.org/drawingml/2006/main">
               <a:ext uri="{FF2B5EF4-FFF2-40B4-BE49-F238E27FC236}">
-                <a16:creationId xmlns:a16="http://schemas.microsoft.com/office/drawing/2014/main" id="{E1754BC5-C3A1-4C8F-906A-03F14D4B6F56}"/>
+                <a16:creationId xmlns:a16="http://schemas.microsoft.com/office/drawing/2014/main" id="{A6756D6A-DE0C-4461-8E96-BEB290A5C11E}"/>
               </a:ext>
             </a:extLst>
           </p:cNvPr>
@@ -10851,7 +10945,7 @@
           <p:cNvPr id="21" name="">
             <a:extLst xmlns:a="http://schemas.openxmlformats.org/drawingml/2006/main">
               <a:ext uri="{FF2B5EF4-FFF2-40B4-BE49-F238E27FC236}">
-                <a16:creationId xmlns:a16="http://schemas.microsoft.com/office/drawing/2014/main" id="{FFFCD408-D0DC-4335-AF84-0640F010CA6C}"/>
+                <a16:creationId xmlns:a16="http://schemas.microsoft.com/office/drawing/2014/main" id="{C062B864-BAC4-46E6-98EC-76D47CC63569}"/>
               </a:ext>
             </a:extLst>
           </p:cNvPr>
@@ -10885,7 +10979,7 @@
           <p:cNvPr id="22" name="">
             <a:extLst xmlns:a="http://schemas.openxmlformats.org/drawingml/2006/main">
               <a:ext uri="{FF2B5EF4-FFF2-40B4-BE49-F238E27FC236}">
-                <a16:creationId xmlns:a16="http://schemas.microsoft.com/office/drawing/2014/main" id="{D91C6015-6B23-4A96-87EE-7A27CFC08321}"/>
+                <a16:creationId xmlns:a16="http://schemas.microsoft.com/office/drawing/2014/main" id="{27A421B3-6A97-4562-9AD5-001AD2D11394}"/>
               </a:ext>
             </a:extLst>
           </p:cNvPr>
@@ -10919,7 +11013,7 @@
           <p:cNvPr id="23" name="">
             <a:extLst xmlns:a="http://schemas.openxmlformats.org/drawingml/2006/main">
               <a:ext uri="{FF2B5EF4-FFF2-40B4-BE49-F238E27FC236}">
-                <a16:creationId xmlns:a16="http://schemas.microsoft.com/office/drawing/2014/main" id="{71468984-81CC-41D7-AEB9-F4CB6E1902BF}"/>
+                <a16:creationId xmlns:a16="http://schemas.microsoft.com/office/drawing/2014/main" id="{D65F3B93-7596-4EE1-8811-F7EC4FA3C18F}"/>
               </a:ext>
             </a:extLst>
           </p:cNvPr>
@@ -10976,7 +11070,7 @@
           <p:cNvPr id="24" name="">
             <a:extLst xmlns:a="http://schemas.openxmlformats.org/drawingml/2006/main">
               <a:ext uri="{FF2B5EF4-FFF2-40B4-BE49-F238E27FC236}">
-                <a16:creationId xmlns:a16="http://schemas.microsoft.com/office/drawing/2014/main" id="{FA51E719-51AC-4301-8214-CABB4983403B}"/>
+                <a16:creationId xmlns:a16="http://schemas.microsoft.com/office/drawing/2014/main" id="{D14E3BBA-7449-444A-9341-0C3E6970C1A9}"/>
               </a:ext>
             </a:extLst>
           </p:cNvPr>
@@ -11033,7 +11127,7 @@
           <p:cNvPr id="25" name="">
             <a:extLst xmlns:a="http://schemas.openxmlformats.org/drawingml/2006/main">
               <a:ext uri="{FF2B5EF4-FFF2-40B4-BE49-F238E27FC236}">
-                <a16:creationId xmlns:a16="http://schemas.microsoft.com/office/drawing/2014/main" id="{9267D154-67E9-40A4-9C50-160FDC17E4B1}"/>
+                <a16:creationId xmlns:a16="http://schemas.microsoft.com/office/drawing/2014/main" id="{45500589-713D-4B62-BD0C-5D878DE06FC9}"/>
               </a:ext>
             </a:extLst>
           </p:cNvPr>
@@ -11063,7 +11157,7 @@
           <p:cNvPr id="26" name="">
             <a:extLst xmlns:a="http://schemas.openxmlformats.org/drawingml/2006/main">
               <a:ext uri="{FF2B5EF4-FFF2-40B4-BE49-F238E27FC236}">
-                <a16:creationId xmlns:a16="http://schemas.microsoft.com/office/drawing/2014/main" id="{07CAD252-A8C1-4F40-80A0-E2358C452827}"/>
+                <a16:creationId xmlns:a16="http://schemas.microsoft.com/office/drawing/2014/main" id="{A7BDA6B7-A109-4B87-948A-5C00EDB996B1}"/>
               </a:ext>
             </a:extLst>
           </p:cNvPr>
@@ -11166,7 +11260,7 @@
           <p:cNvPr id="27" name="">
             <a:extLst xmlns:a="http://schemas.openxmlformats.org/drawingml/2006/main">
               <a:ext uri="{FF2B5EF4-FFF2-40B4-BE49-F238E27FC236}">
-                <a16:creationId xmlns:a16="http://schemas.microsoft.com/office/drawing/2014/main" id="{FA20912E-B8A1-416E-9146-799F6131F67D}"/>
+                <a16:creationId xmlns:a16="http://schemas.microsoft.com/office/drawing/2014/main" id="{8E334D04-2FB3-4B09-ACDD-24309276BF5C}"/>
               </a:ext>
             </a:extLst>
           </p:cNvPr>
@@ -11200,7 +11294,7 @@
           <p:cNvPr id="28" name="">
             <a:extLst xmlns:a="http://schemas.openxmlformats.org/drawingml/2006/main">
               <a:ext uri="{FF2B5EF4-FFF2-40B4-BE49-F238E27FC236}">
-                <a16:creationId xmlns:a16="http://schemas.microsoft.com/office/drawing/2014/main" id="{20DF97F2-5E26-49D3-B213-2460B24A8E62}"/>
+                <a16:creationId xmlns:a16="http://schemas.microsoft.com/office/drawing/2014/main" id="{308BBE2F-0AE2-4D91-8833-7BAFAABCB93A}"/>
               </a:ext>
             </a:extLst>
           </p:cNvPr>
@@ -11257,7 +11351,7 @@
           <p:cNvPr id="29" name="">
             <a:extLst xmlns:a="http://schemas.openxmlformats.org/drawingml/2006/main">
               <a:ext uri="{FF2B5EF4-FFF2-40B4-BE49-F238E27FC236}">
-                <a16:creationId xmlns:a16="http://schemas.microsoft.com/office/drawing/2014/main" id="{383630BE-DDC1-44F8-A7A8-49DC2D927F41}"/>
+                <a16:creationId xmlns:a16="http://schemas.microsoft.com/office/drawing/2014/main" id="{BBB9347C-CCAE-46A0-B08B-FD3053E0BCAE}"/>
               </a:ext>
             </a:extLst>
           </p:cNvPr>
@@ -11289,7 +11383,7 @@
           <p:cNvPr id="30" name="">
             <a:extLst xmlns:a="http://schemas.openxmlformats.org/drawingml/2006/main">
               <a:ext uri="{FF2B5EF4-FFF2-40B4-BE49-F238E27FC236}">
-                <a16:creationId xmlns:a16="http://schemas.microsoft.com/office/drawing/2014/main" id="{EFCDFF14-43A9-4177-85A6-C005AEC8C906}"/>
+                <a16:creationId xmlns:a16="http://schemas.microsoft.com/office/drawing/2014/main" id="{E0166C81-3676-4E60-A01D-8C372B88DD7E}"/>
               </a:ext>
             </a:extLst>
           </p:cNvPr>
@@ -11346,7 +11440,7 @@
           <p:cNvPr id="31" name="">
             <a:extLst xmlns:a="http://schemas.openxmlformats.org/drawingml/2006/main">
               <a:ext uri="{FF2B5EF4-FFF2-40B4-BE49-F238E27FC236}">
-                <a16:creationId xmlns:a16="http://schemas.microsoft.com/office/drawing/2014/main" id="{9703AA16-6667-4B0F-93BF-F2629A145217}"/>
+                <a16:creationId xmlns:a16="http://schemas.microsoft.com/office/drawing/2014/main" id="{C22ECA37-4E97-461D-828C-85A6CD63D8CA}"/>
               </a:ext>
             </a:extLst>
           </p:cNvPr>
@@ -11378,7 +11472,7 @@
           <p:cNvPr id="32" name="">
             <a:extLst xmlns:a="http://schemas.openxmlformats.org/drawingml/2006/main">
               <a:ext uri="{FF2B5EF4-FFF2-40B4-BE49-F238E27FC236}">
-                <a16:creationId xmlns:a16="http://schemas.microsoft.com/office/drawing/2014/main" id="{5A766E8A-F39D-4C86-AC94-B45A13ADC525}"/>
+                <a16:creationId xmlns:a16="http://schemas.microsoft.com/office/drawing/2014/main" id="{2C0457E3-3BEF-408E-BF21-685EE6AFDBB7}"/>
               </a:ext>
             </a:extLst>
           </p:cNvPr>
@@ -11435,7 +11529,7 @@
           <p:cNvPr id="33" name="">
             <a:extLst xmlns:a="http://schemas.openxmlformats.org/drawingml/2006/main">
               <a:ext uri="{FF2B5EF4-FFF2-40B4-BE49-F238E27FC236}">
-                <a16:creationId xmlns:a16="http://schemas.microsoft.com/office/drawing/2014/main" id="{73CECCBE-6CE3-4C5F-B322-17738227C2DA}"/>
+                <a16:creationId xmlns:a16="http://schemas.microsoft.com/office/drawing/2014/main" id="{0C243C06-5842-4397-9F9A-B1AC5ED3EBDD}"/>
               </a:ext>
             </a:extLst>
           </p:cNvPr>
@@ -11467,7 +11561,7 @@
           <p:cNvPr id="34" name="">
             <a:extLst xmlns:a="http://schemas.openxmlformats.org/drawingml/2006/main">
               <a:ext uri="{FF2B5EF4-FFF2-40B4-BE49-F238E27FC236}">
-                <a16:creationId xmlns:a16="http://schemas.microsoft.com/office/drawing/2014/main" id="{681AF17D-3437-4BAE-89C9-957776CA367A}"/>
+                <a16:creationId xmlns:a16="http://schemas.microsoft.com/office/drawing/2014/main" id="{82FBBCC2-A0B6-4BF1-A33E-FF86F5B85D1E}"/>
               </a:ext>
             </a:extLst>
           </p:cNvPr>
@@ -11524,7 +11618,7 @@
           <p:cNvPr id="35" name="">
             <a:extLst xmlns:a="http://schemas.openxmlformats.org/drawingml/2006/main">
               <a:ext uri="{FF2B5EF4-FFF2-40B4-BE49-F238E27FC236}">
-                <a16:creationId xmlns:a16="http://schemas.microsoft.com/office/drawing/2014/main" id="{1CEB82C1-56A7-44F6-947C-2EA9D46A0ECA}"/>
+                <a16:creationId xmlns:a16="http://schemas.microsoft.com/office/drawing/2014/main" id="{43952C08-8BBB-4408-B169-ED8C2EEDD84F}"/>
               </a:ext>
             </a:extLst>
           </p:cNvPr>
@@ -11556,7 +11650,7 @@
           <p:cNvPr id="36" name="">
             <a:extLst xmlns:a="http://schemas.openxmlformats.org/drawingml/2006/main">
               <a:ext uri="{FF2B5EF4-FFF2-40B4-BE49-F238E27FC236}">
-                <a16:creationId xmlns:a16="http://schemas.microsoft.com/office/drawing/2014/main" id="{54938F59-7782-4331-86FC-00E9074AB6FE}"/>
+                <a16:creationId xmlns:a16="http://schemas.microsoft.com/office/drawing/2014/main" id="{C757DEE1-8B5B-45BA-A11D-17C44B95B8C9}"/>
               </a:ext>
             </a:extLst>
           </p:cNvPr>
@@ -11613,7 +11707,7 @@
           <p:cNvPr id="37" name="">
             <a:extLst xmlns:a="http://schemas.openxmlformats.org/drawingml/2006/main">
               <a:ext uri="{FF2B5EF4-FFF2-40B4-BE49-F238E27FC236}">
-                <a16:creationId xmlns:a16="http://schemas.microsoft.com/office/drawing/2014/main" id="{CF8BBF18-F6DB-4FA5-B818-8891B2EAAA3F}"/>
+                <a16:creationId xmlns:a16="http://schemas.microsoft.com/office/drawing/2014/main" id="{EFEAB6C2-2B6E-4A34-B8C0-CC50E18CB329}"/>
               </a:ext>
             </a:extLst>
           </p:cNvPr>
@@ -11670,7 +11764,7 @@
           <p:cNvPr id="38" name="">
             <a:extLst xmlns:a="http://schemas.openxmlformats.org/drawingml/2006/main">
               <a:ext uri="{FF2B5EF4-FFF2-40B4-BE49-F238E27FC236}">
-                <a16:creationId xmlns:a16="http://schemas.microsoft.com/office/drawing/2014/main" id="{7D37AF38-68AC-4C54-8520-66932B7FD40C}"/>
+                <a16:creationId xmlns:a16="http://schemas.microsoft.com/office/drawing/2014/main" id="{DC384448-68DF-4C3B-A2A7-84F742335704}"/>
               </a:ext>
             </a:extLst>
           </p:cNvPr>
@@ -11727,7 +11821,7 @@
           <p:cNvPr id="39" name="">
             <a:extLst xmlns:a="http://schemas.openxmlformats.org/drawingml/2006/main">
               <a:ext uri="{FF2B5EF4-FFF2-40B4-BE49-F238E27FC236}">
-                <a16:creationId xmlns:a16="http://schemas.microsoft.com/office/drawing/2014/main" id="{65047062-3978-4D77-BB19-AF4E6B8D4F13}"/>
+                <a16:creationId xmlns:a16="http://schemas.microsoft.com/office/drawing/2014/main" id="{7E913863-B113-49BE-9830-04000E29F219}"/>
               </a:ext>
             </a:extLst>
           </p:cNvPr>
@@ -11782,7 +11876,7 @@
     </p:spTree>
     <p:extLst>
       <p:ext uri="{BB962C8B-B14F-4D97-AF65-F5344CB8AC3E}">
-        <p14:creationId xmlns:p14="http://schemas.microsoft.com/office/powerpoint/2010/main" val="1593362530"/>
+        <p14:creationId xmlns:p14="http://schemas.microsoft.com/office/powerpoint/2010/main" val="1542004648"/>
       </p:ext>
     </p:extLst>
   </p:cSld>
@@ -11813,7 +11907,7 @@
           <p:cNvPr id="34" name="">
             <a:extLst xmlns:a="http://schemas.openxmlformats.org/drawingml/2006/main">
               <a:ext uri="{FF2B5EF4-FFF2-40B4-BE49-F238E27FC236}">
-                <a16:creationId xmlns:a16="http://schemas.microsoft.com/office/drawing/2014/main" id="{92CD01A5-987E-4CC9-8E56-59CDC26D9EDD}"/>
+                <a16:creationId xmlns:a16="http://schemas.microsoft.com/office/drawing/2014/main" id="{AAE2E95B-5A10-4425-9729-DD6F263537C9}"/>
               </a:ext>
             </a:extLst>
           </p:cNvPr>
@@ -11870,7 +11964,7 @@
           <p:cNvPr id="2" name="">
             <a:extLst xmlns:a="http://schemas.openxmlformats.org/drawingml/2006/main">
               <a:ext uri="{FF2B5EF4-FFF2-40B4-BE49-F238E27FC236}">
-                <a16:creationId xmlns:a16="http://schemas.microsoft.com/office/drawing/2014/main" id="{3F21152A-7689-4DD3-9B44-8D74FF71A11F}"/>
+                <a16:creationId xmlns:a16="http://schemas.microsoft.com/office/drawing/2014/main" id="{A322168F-75C5-4F19-9D7E-4EBBA8E56FEA}"/>
               </a:ext>
             </a:extLst>
           </p:cNvPr>
@@ -11900,7 +11994,7 @@
           <p:cNvPr id="3" name="">
             <a:extLst xmlns:a="http://schemas.openxmlformats.org/drawingml/2006/main">
               <a:ext uri="{FF2B5EF4-FFF2-40B4-BE49-F238E27FC236}">
-                <a16:creationId xmlns:a16="http://schemas.microsoft.com/office/drawing/2014/main" id="{AF9FFAB9-F344-41E2-9EBF-BDFD12572DBA}"/>
+                <a16:creationId xmlns:a16="http://schemas.microsoft.com/office/drawing/2014/main" id="{875EAC67-658B-4B8D-85EE-D9F3135EA5EE}"/>
               </a:ext>
             </a:extLst>
           </p:cNvPr>
@@ -11957,7 +12051,7 @@
           <p:cNvPr id="4" name="">
             <a:extLst xmlns:a="http://schemas.openxmlformats.org/drawingml/2006/main">
               <a:ext uri="{FF2B5EF4-FFF2-40B4-BE49-F238E27FC236}">
-                <a16:creationId xmlns:a16="http://schemas.microsoft.com/office/drawing/2014/main" id="{27051CC4-804D-47FD-A44A-5812EFE5C957}"/>
+                <a16:creationId xmlns:a16="http://schemas.microsoft.com/office/drawing/2014/main" id="{C0993E2D-24EB-4EE5-8241-EC9B35DB06E0}"/>
               </a:ext>
             </a:extLst>
           </p:cNvPr>
@@ -12014,7 +12108,7 @@
           <p:cNvPr id="5" name="">
             <a:extLst xmlns:a="http://schemas.openxmlformats.org/drawingml/2006/main">
               <a:ext uri="{FF2B5EF4-FFF2-40B4-BE49-F238E27FC236}">
-                <a16:creationId xmlns:a16="http://schemas.microsoft.com/office/drawing/2014/main" id="{6047F687-39DE-4332-B6DE-D497BB9B2F6B}"/>
+                <a16:creationId xmlns:a16="http://schemas.microsoft.com/office/drawing/2014/main" id="{766705E5-95E5-4765-BEBF-78DF4B517659}"/>
               </a:ext>
             </a:extLst>
           </p:cNvPr>
@@ -12044,7 +12138,7 @@
           <p:cNvPr id="6" name="">
             <a:extLst xmlns:a="http://schemas.openxmlformats.org/drawingml/2006/main">
               <a:ext uri="{FF2B5EF4-FFF2-40B4-BE49-F238E27FC236}">
-                <a16:creationId xmlns:a16="http://schemas.microsoft.com/office/drawing/2014/main" id="{D774416C-6D1E-4CE3-B887-1F17AF942629}"/>
+                <a16:creationId xmlns:a16="http://schemas.microsoft.com/office/drawing/2014/main" id="{6418DC40-FD12-4179-A280-AE6C13C0EA04}"/>
               </a:ext>
             </a:extLst>
           </p:cNvPr>
@@ -12101,7 +12195,7 @@
           <p:cNvPr id="7" name="">
             <a:extLst xmlns:a="http://schemas.openxmlformats.org/drawingml/2006/main">
               <a:ext uri="{FF2B5EF4-FFF2-40B4-BE49-F238E27FC236}">
-                <a16:creationId xmlns:a16="http://schemas.microsoft.com/office/drawing/2014/main" id="{33635BB2-EA95-4139-B1C2-BD468CEF8B7C}"/>
+                <a16:creationId xmlns:a16="http://schemas.microsoft.com/office/drawing/2014/main" id="{9219EAC2-437C-45B4-A28D-C244CCA616E1}"/>
               </a:ext>
             </a:extLst>
           </p:cNvPr>
@@ -12158,7 +12252,7 @@
           <p:cNvPr id="8" name="">
             <a:extLst xmlns:a="http://schemas.openxmlformats.org/drawingml/2006/main">
               <a:ext uri="{FF2B5EF4-FFF2-40B4-BE49-F238E27FC236}">
-                <a16:creationId xmlns:a16="http://schemas.microsoft.com/office/drawing/2014/main" id="{5742EBDC-FB1A-4942-9426-55CF707DC346}"/>
+                <a16:creationId xmlns:a16="http://schemas.microsoft.com/office/drawing/2014/main" id="{5496C041-61B1-441C-9900-61E26273A483}"/>
               </a:ext>
             </a:extLst>
           </p:cNvPr>
@@ -12215,7 +12309,7 @@
           <p:cNvPr id="9" name="">
             <a:extLst xmlns:a="http://schemas.openxmlformats.org/drawingml/2006/main">
               <a:ext uri="{FF2B5EF4-FFF2-40B4-BE49-F238E27FC236}">
-                <a16:creationId xmlns:a16="http://schemas.microsoft.com/office/drawing/2014/main" id="{551AB570-E3FB-4A31-B428-623F9A556879}"/>
+                <a16:creationId xmlns:a16="http://schemas.microsoft.com/office/drawing/2014/main" id="{1693D5D7-6D5C-410D-9BFB-130C18D93A13}"/>
               </a:ext>
             </a:extLst>
           </p:cNvPr>
@@ -12272,7 +12366,7 @@
           <p:cNvPr id="10" name="">
             <a:extLst xmlns:a="http://schemas.openxmlformats.org/drawingml/2006/main">
               <a:ext uri="{FF2B5EF4-FFF2-40B4-BE49-F238E27FC236}">
-                <a16:creationId xmlns:a16="http://schemas.microsoft.com/office/drawing/2014/main" id="{C69CE6C0-923C-4F09-AB80-B5DA6BAA07AC}"/>
+                <a16:creationId xmlns:a16="http://schemas.microsoft.com/office/drawing/2014/main" id="{002BAF30-B10F-409F-B18F-A67ED4457589}"/>
               </a:ext>
             </a:extLst>
           </p:cNvPr>
@@ -12329,7 +12423,7 @@
           <p:cNvPr id="11" name="">
             <a:extLst xmlns:a="http://schemas.openxmlformats.org/drawingml/2006/main">
               <a:ext uri="{FF2B5EF4-FFF2-40B4-BE49-F238E27FC236}">
-                <a16:creationId xmlns:a16="http://schemas.microsoft.com/office/drawing/2014/main" id="{BDE6AF7F-3688-444D-8E7D-219A28ED7C36}"/>
+                <a16:creationId xmlns:a16="http://schemas.microsoft.com/office/drawing/2014/main" id="{E2415560-11F5-457B-837C-A98ED0E63794}"/>
               </a:ext>
             </a:extLst>
           </p:cNvPr>
@@ -12363,7 +12457,7 @@
           <p:cNvPr id="12" name="">
             <a:extLst xmlns:a="http://schemas.openxmlformats.org/drawingml/2006/main">
               <a:ext uri="{FF2B5EF4-FFF2-40B4-BE49-F238E27FC236}">
-                <a16:creationId xmlns:a16="http://schemas.microsoft.com/office/drawing/2014/main" id="{0D48F6CC-67A4-4996-A68A-F2336FED7BA7}"/>
+                <a16:creationId xmlns:a16="http://schemas.microsoft.com/office/drawing/2014/main" id="{DC80BD84-6D15-49D8-86BB-E7B75DD15BA3}"/>
               </a:ext>
             </a:extLst>
           </p:cNvPr>
@@ -12420,7 +12514,7 @@
           <p:cNvPr id="13" name="">
             <a:extLst xmlns:a="http://schemas.openxmlformats.org/drawingml/2006/main">
               <a:ext uri="{FF2B5EF4-FFF2-40B4-BE49-F238E27FC236}">
-                <a16:creationId xmlns:a16="http://schemas.microsoft.com/office/drawing/2014/main" id="{D55A2A31-F163-4957-BD15-5166344E7A51}"/>
+                <a16:creationId xmlns:a16="http://schemas.microsoft.com/office/drawing/2014/main" id="{058B43D2-7BF1-4705-BA49-FBC3D3FE4250}"/>
               </a:ext>
             </a:extLst>
           </p:cNvPr>
@@ -12477,7 +12571,7 @@
           <p:cNvPr id="14" name="">
             <a:extLst xmlns:a="http://schemas.openxmlformats.org/drawingml/2006/main">
               <a:ext uri="{FF2B5EF4-FFF2-40B4-BE49-F238E27FC236}">
-                <a16:creationId xmlns:a16="http://schemas.microsoft.com/office/drawing/2014/main" id="{C9C4BC93-FB2D-406F-977A-928BB82F860E}"/>
+                <a16:creationId xmlns:a16="http://schemas.microsoft.com/office/drawing/2014/main" id="{E492F273-8CE7-4B03-AC5E-563C73D7C1DC}"/>
               </a:ext>
             </a:extLst>
           </p:cNvPr>
@@ -12511,7 +12605,7 @@
           <p:cNvPr id="15" name="">
             <a:extLst xmlns:a="http://schemas.openxmlformats.org/drawingml/2006/main">
               <a:ext uri="{FF2B5EF4-FFF2-40B4-BE49-F238E27FC236}">
-                <a16:creationId xmlns:a16="http://schemas.microsoft.com/office/drawing/2014/main" id="{C70C5C6F-424A-4BEB-A0C0-A8F2DB3083FC}"/>
+                <a16:creationId xmlns:a16="http://schemas.microsoft.com/office/drawing/2014/main" id="{890ECC53-FE1C-4093-AFD5-AB024FAE2F1A}"/>
               </a:ext>
             </a:extLst>
           </p:cNvPr>
@@ -12568,7 +12662,7 @@
           <p:cNvPr id="16" name="">
             <a:extLst xmlns:a="http://schemas.openxmlformats.org/drawingml/2006/main">
               <a:ext uri="{FF2B5EF4-FFF2-40B4-BE49-F238E27FC236}">
-                <a16:creationId xmlns:a16="http://schemas.microsoft.com/office/drawing/2014/main" id="{B7B04C97-705C-4543-869E-B8C53ECF660D}"/>
+                <a16:creationId xmlns:a16="http://schemas.microsoft.com/office/drawing/2014/main" id="{9DCD94C5-3B2B-4B27-9E7B-07E24E7EF2D5}"/>
               </a:ext>
             </a:extLst>
           </p:cNvPr>
@@ -12602,7 +12696,7 @@
           <p:cNvPr id="17" name="">
             <a:extLst xmlns:a="http://schemas.openxmlformats.org/drawingml/2006/main">
               <a:ext uri="{FF2B5EF4-FFF2-40B4-BE49-F238E27FC236}">
-                <a16:creationId xmlns:a16="http://schemas.microsoft.com/office/drawing/2014/main" id="{73B91DA0-C919-4584-A2CA-598345132B0C}"/>
+                <a16:creationId xmlns:a16="http://schemas.microsoft.com/office/drawing/2014/main" id="{3DEC3F77-84F5-45CC-B129-1DB634B1249C}"/>
               </a:ext>
             </a:extLst>
           </p:cNvPr>
@@ -12659,7 +12753,7 @@
           <p:cNvPr id="18" name="">
             <a:extLst xmlns:a="http://schemas.openxmlformats.org/drawingml/2006/main">
               <a:ext uri="{FF2B5EF4-FFF2-40B4-BE49-F238E27FC236}">
-                <a16:creationId xmlns:a16="http://schemas.microsoft.com/office/drawing/2014/main" id="{9E70D5AF-D34B-42F9-96E9-59AA0FADABDD}"/>
+                <a16:creationId xmlns:a16="http://schemas.microsoft.com/office/drawing/2014/main" id="{BDA65E81-9077-4B70-8AD8-854AB93B85AB}"/>
               </a:ext>
             </a:extLst>
           </p:cNvPr>
@@ -12716,7 +12810,7 @@
           <p:cNvPr id="19" name="">
             <a:extLst xmlns:a="http://schemas.openxmlformats.org/drawingml/2006/main">
               <a:ext uri="{FF2B5EF4-FFF2-40B4-BE49-F238E27FC236}">
-                <a16:creationId xmlns:a16="http://schemas.microsoft.com/office/drawing/2014/main" id="{BDC0AAD4-554D-46EE-89F1-837E38E29874}"/>
+                <a16:creationId xmlns:a16="http://schemas.microsoft.com/office/drawing/2014/main" id="{75125290-B926-44F1-B756-4E9C622D852E}"/>
               </a:ext>
             </a:extLst>
           </p:cNvPr>
@@ -12750,7 +12844,7 @@
           <p:cNvPr id="20" name="">
             <a:extLst xmlns:a="http://schemas.openxmlformats.org/drawingml/2006/main">
               <a:ext uri="{FF2B5EF4-FFF2-40B4-BE49-F238E27FC236}">
-                <a16:creationId xmlns:a16="http://schemas.microsoft.com/office/drawing/2014/main" id="{7CE360B5-6D09-4E0F-9B52-3833875C98CA}"/>
+                <a16:creationId xmlns:a16="http://schemas.microsoft.com/office/drawing/2014/main" id="{7557343A-A0E0-4A20-964F-8889957E837E}"/>
               </a:ext>
             </a:extLst>
           </p:cNvPr>
@@ -12807,7 +12901,7 @@
           <p:cNvPr id="21" name="">
             <a:extLst xmlns:a="http://schemas.openxmlformats.org/drawingml/2006/main">
               <a:ext uri="{FF2B5EF4-FFF2-40B4-BE49-F238E27FC236}">
-                <a16:creationId xmlns:a16="http://schemas.microsoft.com/office/drawing/2014/main" id="{99EE7B56-C042-4407-837B-72F18F68B194}"/>
+                <a16:creationId xmlns:a16="http://schemas.microsoft.com/office/drawing/2014/main" id="{A3275BD6-8212-466B-B641-73909FB59837}"/>
               </a:ext>
             </a:extLst>
           </p:cNvPr>
@@ -12841,7 +12935,7 @@
           <p:cNvPr id="22" name="">
             <a:extLst xmlns:a="http://schemas.openxmlformats.org/drawingml/2006/main">
               <a:ext uri="{FF2B5EF4-FFF2-40B4-BE49-F238E27FC236}">
-                <a16:creationId xmlns:a16="http://schemas.microsoft.com/office/drawing/2014/main" id="{11F9CADA-8A8C-40C5-AE7A-3B9A4FBEDF36}"/>
+                <a16:creationId xmlns:a16="http://schemas.microsoft.com/office/drawing/2014/main" id="{3F7DFCBB-F424-486C-9580-3978AC9432BB}"/>
               </a:ext>
             </a:extLst>
           </p:cNvPr>
@@ -12898,7 +12992,7 @@
           <p:cNvPr id="23" name="">
             <a:extLst xmlns:a="http://schemas.openxmlformats.org/drawingml/2006/main">
               <a:ext uri="{FF2B5EF4-FFF2-40B4-BE49-F238E27FC236}">
-                <a16:creationId xmlns:a16="http://schemas.microsoft.com/office/drawing/2014/main" id="{46D5E1F5-0EDD-4325-BDC8-6BEE4318951B}"/>
+                <a16:creationId xmlns:a16="http://schemas.microsoft.com/office/drawing/2014/main" id="{61DA99B4-D773-4452-958E-F74F28B4E86E}"/>
               </a:ext>
             </a:extLst>
           </p:cNvPr>
@@ -12955,7 +13049,7 @@
           <p:cNvPr id="24" name="">
             <a:extLst xmlns:a="http://schemas.openxmlformats.org/drawingml/2006/main">
               <a:ext uri="{FF2B5EF4-FFF2-40B4-BE49-F238E27FC236}">
-                <a16:creationId xmlns:a16="http://schemas.microsoft.com/office/drawing/2014/main" id="{E2EB7CF8-1DF0-4779-89DB-42356F4C6BA5}"/>
+                <a16:creationId xmlns:a16="http://schemas.microsoft.com/office/drawing/2014/main" id="{5DA8A415-8448-4C31-81AE-83BCE42DE5A4}"/>
               </a:ext>
             </a:extLst>
           </p:cNvPr>
@@ -12989,7 +13083,7 @@
           <p:cNvPr id="25" name="">
             <a:extLst xmlns:a="http://schemas.openxmlformats.org/drawingml/2006/main">
               <a:ext uri="{FF2B5EF4-FFF2-40B4-BE49-F238E27FC236}">
-                <a16:creationId xmlns:a16="http://schemas.microsoft.com/office/drawing/2014/main" id="{A9D304EE-9E0F-4210-9F42-5E5EC4AABAB7}"/>
+                <a16:creationId xmlns:a16="http://schemas.microsoft.com/office/drawing/2014/main" id="{D758695F-DD5A-4DB1-BF21-0BDD87DC7B6C}"/>
               </a:ext>
             </a:extLst>
           </p:cNvPr>
@@ -13046,7 +13140,7 @@
           <p:cNvPr id="26" name="">
             <a:extLst xmlns:a="http://schemas.openxmlformats.org/drawingml/2006/main">
               <a:ext uri="{FF2B5EF4-FFF2-40B4-BE49-F238E27FC236}">
-                <a16:creationId xmlns:a16="http://schemas.microsoft.com/office/drawing/2014/main" id="{318097C7-387B-40DE-B2A7-3BF576329D2E}"/>
+                <a16:creationId xmlns:a16="http://schemas.microsoft.com/office/drawing/2014/main" id="{3FA9BDE0-4AA8-4E79-A2DB-412A05E59AFE}"/>
               </a:ext>
             </a:extLst>
           </p:cNvPr>
@@ -13080,7 +13174,7 @@
           <p:cNvPr id="27" name="">
             <a:extLst xmlns:a="http://schemas.openxmlformats.org/drawingml/2006/main">
               <a:ext uri="{FF2B5EF4-FFF2-40B4-BE49-F238E27FC236}">
-                <a16:creationId xmlns:a16="http://schemas.microsoft.com/office/drawing/2014/main" id="{F3D7E640-71A2-4845-A3D0-D1980179F700}"/>
+                <a16:creationId xmlns:a16="http://schemas.microsoft.com/office/drawing/2014/main" id="{AF2309BD-AD18-43D7-B0BF-B3675D5FA79F}"/>
               </a:ext>
             </a:extLst>
           </p:cNvPr>
@@ -13137,7 +13231,7 @@
           <p:cNvPr id="28" name="">
             <a:extLst xmlns:a="http://schemas.openxmlformats.org/drawingml/2006/main">
               <a:ext uri="{FF2B5EF4-FFF2-40B4-BE49-F238E27FC236}">
-                <a16:creationId xmlns:a16="http://schemas.microsoft.com/office/drawing/2014/main" id="{CE86BC2C-8A14-4DD0-BB7D-CF3F6BD01A02}"/>
+                <a16:creationId xmlns:a16="http://schemas.microsoft.com/office/drawing/2014/main" id="{DE37F6CD-338A-4042-82DB-5A197D3623E0}"/>
               </a:ext>
             </a:extLst>
           </p:cNvPr>
@@ -13194,7 +13288,7 @@
           <p:cNvPr id="29" name="">
             <a:extLst xmlns:a="http://schemas.openxmlformats.org/drawingml/2006/main">
               <a:ext uri="{FF2B5EF4-FFF2-40B4-BE49-F238E27FC236}">
-                <a16:creationId xmlns:a16="http://schemas.microsoft.com/office/drawing/2014/main" id="{7DD151D7-6FBC-4E45-8A94-D0136D83E756}"/>
+                <a16:creationId xmlns:a16="http://schemas.microsoft.com/office/drawing/2014/main" id="{58B635E1-77C4-4ACD-9DCC-06C71317151F}"/>
               </a:ext>
             </a:extLst>
           </p:cNvPr>
@@ -13228,7 +13322,7 @@
           <p:cNvPr id="30" name="">
             <a:extLst xmlns:a="http://schemas.openxmlformats.org/drawingml/2006/main">
               <a:ext uri="{FF2B5EF4-FFF2-40B4-BE49-F238E27FC236}">
-                <a16:creationId xmlns:a16="http://schemas.microsoft.com/office/drawing/2014/main" id="{DA4FBE69-0363-4BAC-BF27-AF21AA9B588B}"/>
+                <a16:creationId xmlns:a16="http://schemas.microsoft.com/office/drawing/2014/main" id="{6B3D3961-91A4-4D55-B3F3-F3C97E95DD24}"/>
               </a:ext>
             </a:extLst>
           </p:cNvPr>
@@ -13285,7 +13379,7 @@
           <p:cNvPr id="31" name="">
             <a:extLst xmlns:a="http://schemas.openxmlformats.org/drawingml/2006/main">
               <a:ext uri="{FF2B5EF4-FFF2-40B4-BE49-F238E27FC236}">
-                <a16:creationId xmlns:a16="http://schemas.microsoft.com/office/drawing/2014/main" id="{ABF9536D-BFFF-4CF9-922D-45AB3EDD61DF}"/>
+                <a16:creationId xmlns:a16="http://schemas.microsoft.com/office/drawing/2014/main" id="{CDA7D208-D9F3-4A23-8216-F4A313D41604}"/>
               </a:ext>
             </a:extLst>
           </p:cNvPr>
@@ -13319,7 +13413,7 @@
           <p:cNvPr id="32" name="">
             <a:extLst xmlns:a="http://schemas.openxmlformats.org/drawingml/2006/main">
               <a:ext uri="{FF2B5EF4-FFF2-40B4-BE49-F238E27FC236}">
-                <a16:creationId xmlns:a16="http://schemas.microsoft.com/office/drawing/2014/main" id="{C43F0E35-F740-45A6-9FA7-BD90BB61E23F}"/>
+                <a16:creationId xmlns:a16="http://schemas.microsoft.com/office/drawing/2014/main" id="{FD593E0C-5D97-4415-A4A1-414F1E3BD18B}"/>
               </a:ext>
             </a:extLst>
           </p:cNvPr>
@@ -13399,7 +13493,7 @@
           <p:cNvPr id="33" name="">
             <a:extLst xmlns:a="http://schemas.openxmlformats.org/drawingml/2006/main">
               <a:ext uri="{FF2B5EF4-FFF2-40B4-BE49-F238E27FC236}">
-                <a16:creationId xmlns:a16="http://schemas.microsoft.com/office/drawing/2014/main" id="{B687253F-B2E8-4E1F-88C2-49AA4DDCD046}"/>
+                <a16:creationId xmlns:a16="http://schemas.microsoft.com/office/drawing/2014/main" id="{12AB0F9C-F042-49F3-BA50-F622B1717BAE}"/>
               </a:ext>
             </a:extLst>
           </p:cNvPr>
@@ -13454,7 +13548,7 @@
     </p:spTree>
     <p:extLst>
       <p:ext uri="{BB962C8B-B14F-4D97-AF65-F5344CB8AC3E}">
-        <p14:creationId xmlns:p14="http://schemas.microsoft.com/office/powerpoint/2010/main" val="437580690"/>
+        <p14:creationId xmlns:p14="http://schemas.microsoft.com/office/powerpoint/2010/main" val="1735754249"/>
       </p:ext>
     </p:extLst>
   </p:cSld>

</xml_diff>